<commit_message>
chunk 1-3 überarbeitet von Erik
</commit_message>
<xml_diff>
--- a/Lectures/Chunk 2 - Variables and Arithmetic Operators.pptx
+++ b/Lectures/Chunk 2 - Variables and Arithmetic Operators.pptx
@@ -134,868 +134,6 @@
 </p1510:revInfo>
 </file>
 
-<file path=ppt/changesInfos/changesInfo1.xml><?xml version="1.0" encoding="utf-8"?>
-<pc:chgInfo xmlns:a="http://schemas.openxmlformats.org/drawingml/2006/main" xmlns:r="http://schemas.openxmlformats.org/officeDocument/2006/relationships" xmlns:ac="http://schemas.microsoft.com/office/drawing/2013/main/command" xmlns:pc="http://schemas.microsoft.com/office/powerpoint/2013/main/command">
-  <pc:docChgLst>
-    <pc:chgData name="Jonathan Bollig" userId="8b5d0afe-f106-45e0-8c3f-fd98fa124db1" providerId="ADAL" clId="{C3A55AB0-6544-4EF6-B5EC-CEC27959DC72}"/>
-    <pc:docChg chg="addSld delSld modSld">
-      <pc:chgData name="Jonathan Bollig" userId="8b5d0afe-f106-45e0-8c3f-fd98fa124db1" providerId="ADAL" clId="{C3A55AB0-6544-4EF6-B5EC-CEC27959DC72}" dt="2025-08-18T12:44:17.988" v="12" actId="47"/>
-      <pc:docMkLst>
-        <pc:docMk/>
-      </pc:docMkLst>
-      <pc:sldChg chg="modSp mod">
-        <pc:chgData name="Jonathan Bollig" userId="8b5d0afe-f106-45e0-8c3f-fd98fa124db1" providerId="ADAL" clId="{C3A55AB0-6544-4EF6-B5EC-CEC27959DC72}" dt="2025-08-18T12:33:03.261" v="11" actId="20577"/>
-        <pc:sldMkLst>
-          <pc:docMk/>
-          <pc:sldMk cId="836289018" sldId="256"/>
-        </pc:sldMkLst>
-      </pc:sldChg>
-      <pc:sldChg chg="del">
-        <pc:chgData name="Jonathan Bollig" userId="8b5d0afe-f106-45e0-8c3f-fd98fa124db1" providerId="ADAL" clId="{C3A55AB0-6544-4EF6-B5EC-CEC27959DC72}" dt="2025-08-18T12:44:17.988" v="12" actId="47"/>
-        <pc:sldMkLst>
-          <pc:docMk/>
-          <pc:sldMk cId="2169503629" sldId="259"/>
-        </pc:sldMkLst>
-      </pc:sldChg>
-      <pc:sldChg chg="add">
-        <pc:chgData name="Jonathan Bollig" userId="8b5d0afe-f106-45e0-8c3f-fd98fa124db1" providerId="ADAL" clId="{C3A55AB0-6544-4EF6-B5EC-CEC27959DC72}" dt="2025-08-18T12:32:51.254" v="0"/>
-        <pc:sldMkLst>
-          <pc:docMk/>
-          <pc:sldMk cId="289564934" sldId="265"/>
-        </pc:sldMkLst>
-      </pc:sldChg>
-    </pc:docChg>
-  </pc:docChgLst>
-  <pc:docChgLst>
-    <pc:chgData name="Jonathan Bollig" userId="8b5d0afe-f106-45e0-8c3f-fd98fa124db1" providerId="ADAL" clId="{891409C9-2319-433B-8001-2E1CE368518E}"/>
-    <pc:docChg chg="custSel delSld modSld">
-      <pc:chgData name="Jonathan Bollig" userId="8b5d0afe-f106-45e0-8c3f-fd98fa124db1" providerId="ADAL" clId="{891409C9-2319-433B-8001-2E1CE368518E}" dt="2025-08-18T10:03:43.371" v="44" actId="1076"/>
-      <pc:docMkLst>
-        <pc:docMk/>
-      </pc:docMkLst>
-      <pc:sldChg chg="modSp mod">
-        <pc:chgData name="Jonathan Bollig" userId="8b5d0afe-f106-45e0-8c3f-fd98fa124db1" providerId="ADAL" clId="{891409C9-2319-433B-8001-2E1CE368518E}" dt="2025-08-18T10:03:07.320" v="7" actId="20577"/>
-        <pc:sldMkLst>
-          <pc:docMk/>
-          <pc:sldMk cId="836289018" sldId="256"/>
-        </pc:sldMkLst>
-      </pc:sldChg>
-      <pc:sldChg chg="del">
-        <pc:chgData name="Jonathan Bollig" userId="8b5d0afe-f106-45e0-8c3f-fd98fa124db1" providerId="ADAL" clId="{891409C9-2319-433B-8001-2E1CE368518E}" dt="2025-08-18T09:57:07.527" v="0" actId="47"/>
-        <pc:sldMkLst>
-          <pc:docMk/>
-          <pc:sldMk cId="3656329933" sldId="257"/>
-        </pc:sldMkLst>
-      </pc:sldChg>
-      <pc:sldChg chg="del">
-        <pc:chgData name="Jonathan Bollig" userId="8b5d0afe-f106-45e0-8c3f-fd98fa124db1" providerId="ADAL" clId="{891409C9-2319-433B-8001-2E1CE368518E}" dt="2025-08-18T09:57:07.527" v="0" actId="47"/>
-        <pc:sldMkLst>
-          <pc:docMk/>
-          <pc:sldMk cId="544279955" sldId="258"/>
-        </pc:sldMkLst>
-      </pc:sldChg>
-      <pc:sldChg chg="delSp modSp mod">
-        <pc:chgData name="Jonathan Bollig" userId="8b5d0afe-f106-45e0-8c3f-fd98fa124db1" providerId="ADAL" clId="{891409C9-2319-433B-8001-2E1CE368518E}" dt="2025-08-18T10:03:43.371" v="44" actId="1076"/>
-        <pc:sldMkLst>
-          <pc:docMk/>
-          <pc:sldMk cId="2169503629" sldId="259"/>
-        </pc:sldMkLst>
-      </pc:sldChg>
-      <pc:sldChg chg="del">
-        <pc:chgData name="Jonathan Bollig" userId="8b5d0afe-f106-45e0-8c3f-fd98fa124db1" providerId="ADAL" clId="{891409C9-2319-433B-8001-2E1CE368518E}" dt="2025-08-18T09:57:07.527" v="0" actId="47"/>
-        <pc:sldMkLst>
-          <pc:docMk/>
-          <pc:sldMk cId="2533283895" sldId="260"/>
-        </pc:sldMkLst>
-      </pc:sldChg>
-      <pc:sldChg chg="del">
-        <pc:chgData name="Jonathan Bollig" userId="8b5d0afe-f106-45e0-8c3f-fd98fa124db1" providerId="ADAL" clId="{891409C9-2319-433B-8001-2E1CE368518E}" dt="2025-08-18T09:57:07.527" v="0" actId="47"/>
-        <pc:sldMkLst>
-          <pc:docMk/>
-          <pc:sldMk cId="847849653" sldId="261"/>
-        </pc:sldMkLst>
-      </pc:sldChg>
-      <pc:sldChg chg="del">
-        <pc:chgData name="Jonathan Bollig" userId="8b5d0afe-f106-45e0-8c3f-fd98fa124db1" providerId="ADAL" clId="{891409C9-2319-433B-8001-2E1CE368518E}" dt="2025-08-18T09:57:07.527" v="0" actId="47"/>
-        <pc:sldMkLst>
-          <pc:docMk/>
-          <pc:sldMk cId="1908144578" sldId="262"/>
-        </pc:sldMkLst>
-      </pc:sldChg>
-      <pc:sldChg chg="del">
-        <pc:chgData name="Jonathan Bollig" userId="8b5d0afe-f106-45e0-8c3f-fd98fa124db1" providerId="ADAL" clId="{891409C9-2319-433B-8001-2E1CE368518E}" dt="2025-08-18T09:57:07.527" v="0" actId="47"/>
-        <pc:sldMkLst>
-          <pc:docMk/>
-          <pc:sldMk cId="4076698392" sldId="263"/>
-        </pc:sldMkLst>
-      </pc:sldChg>
-      <pc:sldChg chg="del">
-        <pc:chgData name="Jonathan Bollig" userId="8b5d0afe-f106-45e0-8c3f-fd98fa124db1" providerId="ADAL" clId="{891409C9-2319-433B-8001-2E1CE368518E}" dt="2025-08-18T09:57:07.527" v="0" actId="47"/>
-        <pc:sldMkLst>
-          <pc:docMk/>
-          <pc:sldMk cId="3708449378" sldId="264"/>
-        </pc:sldMkLst>
-      </pc:sldChg>
-      <pc:sldChg chg="del">
-        <pc:chgData name="Jonathan Bollig" userId="8b5d0afe-f106-45e0-8c3f-fd98fa124db1" providerId="ADAL" clId="{891409C9-2319-433B-8001-2E1CE368518E}" dt="2025-08-18T09:57:07.527" v="0" actId="47"/>
-        <pc:sldMkLst>
-          <pc:docMk/>
-          <pc:sldMk cId="933916611" sldId="265"/>
-        </pc:sldMkLst>
-      </pc:sldChg>
-      <pc:sldChg chg="del">
-        <pc:chgData name="Jonathan Bollig" userId="8b5d0afe-f106-45e0-8c3f-fd98fa124db1" providerId="ADAL" clId="{891409C9-2319-433B-8001-2E1CE368518E}" dt="2025-08-18T09:57:07.527" v="0" actId="47"/>
-        <pc:sldMkLst>
-          <pc:docMk/>
-          <pc:sldMk cId="2117799034" sldId="266"/>
-        </pc:sldMkLst>
-      </pc:sldChg>
-    </pc:docChg>
-  </pc:docChgLst>
-  <pc:docChgLst>
-    <pc:chgData name="Jonathan Bollig" userId="8b5d0afe-f106-45e0-8c3f-fd98fa124db1" providerId="ADAL" clId="{B108959E-8160-4214-BA0D-42D2F1070C03}"/>
-    <pc:docChg chg="undo custSel addSld modSld sldOrd">
-      <pc:chgData name="Jonathan Bollig" userId="8b5d0afe-f106-45e0-8c3f-fd98fa124db1" providerId="ADAL" clId="{B108959E-8160-4214-BA0D-42D2F1070C03}" dt="2025-08-18T09:38:51.161" v="3588" actId="20577"/>
-      <pc:docMkLst>
-        <pc:docMk/>
-      </pc:docMkLst>
-      <pc:sldChg chg="modSp new mod">
-        <pc:chgData name="Jonathan Bollig" userId="8b5d0afe-f106-45e0-8c3f-fd98fa124db1" providerId="ADAL" clId="{B108959E-8160-4214-BA0D-42D2F1070C03}" dt="2025-08-17T16:47:18.038" v="2214" actId="790"/>
-        <pc:sldMkLst>
-          <pc:docMk/>
-          <pc:sldMk cId="836289018" sldId="256"/>
-        </pc:sldMkLst>
-      </pc:sldChg>
-      <pc:sldChg chg="modSp new mod">
-        <pc:chgData name="Jonathan Bollig" userId="8b5d0afe-f106-45e0-8c3f-fd98fa124db1" providerId="ADAL" clId="{B108959E-8160-4214-BA0D-42D2F1070C03}" dt="2025-08-17T16:47:18.038" v="2214" actId="790"/>
-        <pc:sldMkLst>
-          <pc:docMk/>
-          <pc:sldMk cId="3656329933" sldId="257"/>
-        </pc:sldMkLst>
-      </pc:sldChg>
-      <pc:sldChg chg="addSp delSp modSp new mod modNotesTx">
-        <pc:chgData name="Jonathan Bollig" userId="8b5d0afe-f106-45e0-8c3f-fd98fa124db1" providerId="ADAL" clId="{B108959E-8160-4214-BA0D-42D2F1070C03}" dt="2025-08-18T09:08:46.312" v="2773" actId="20577"/>
-        <pc:sldMkLst>
-          <pc:docMk/>
-          <pc:sldMk cId="544279955" sldId="258"/>
-        </pc:sldMkLst>
-      </pc:sldChg>
-      <pc:sldChg chg="addSp modSp new mod">
-        <pc:chgData name="Jonathan Bollig" userId="8b5d0afe-f106-45e0-8c3f-fd98fa124db1" providerId="ADAL" clId="{B108959E-8160-4214-BA0D-42D2F1070C03}" dt="2025-08-17T17:17:31.026" v="2605" actId="20577"/>
-        <pc:sldMkLst>
-          <pc:docMk/>
-          <pc:sldMk cId="2169503629" sldId="259"/>
-        </pc:sldMkLst>
-      </pc:sldChg>
-      <pc:sldChg chg="modSp new mod">
-        <pc:chgData name="Jonathan Bollig" userId="8b5d0afe-f106-45e0-8c3f-fd98fa124db1" providerId="ADAL" clId="{B108959E-8160-4214-BA0D-42D2F1070C03}" dt="2025-08-18T09:38:51.161" v="3588" actId="20577"/>
-        <pc:sldMkLst>
-          <pc:docMk/>
-          <pc:sldMk cId="2533283895" sldId="260"/>
-        </pc:sldMkLst>
-      </pc:sldChg>
-      <pc:sldChg chg="addSp delSp modSp new mod setBg">
-        <pc:chgData name="Jonathan Bollig" userId="8b5d0afe-f106-45e0-8c3f-fd98fa124db1" providerId="ADAL" clId="{B108959E-8160-4214-BA0D-42D2F1070C03}" dt="2025-08-17T17:07:09.185" v="2483" actId="5793"/>
-        <pc:sldMkLst>
-          <pc:docMk/>
-          <pc:sldMk cId="847849653" sldId="261"/>
-        </pc:sldMkLst>
-      </pc:sldChg>
-      <pc:sldChg chg="modSp new mod">
-        <pc:chgData name="Jonathan Bollig" userId="8b5d0afe-f106-45e0-8c3f-fd98fa124db1" providerId="ADAL" clId="{B108959E-8160-4214-BA0D-42D2F1070C03}" dt="2025-08-17T16:47:18.038" v="2214" actId="790"/>
-        <pc:sldMkLst>
-          <pc:docMk/>
-          <pc:sldMk cId="1908144578" sldId="262"/>
-        </pc:sldMkLst>
-      </pc:sldChg>
-      <pc:sldChg chg="modSp new mod">
-        <pc:chgData name="Jonathan Bollig" userId="8b5d0afe-f106-45e0-8c3f-fd98fa124db1" providerId="ADAL" clId="{B108959E-8160-4214-BA0D-42D2F1070C03}" dt="2025-08-17T16:47:18.038" v="2214" actId="790"/>
-        <pc:sldMkLst>
-          <pc:docMk/>
-          <pc:sldMk cId="4076698392" sldId="263"/>
-        </pc:sldMkLst>
-      </pc:sldChg>
-      <pc:sldChg chg="modSp new mod">
-        <pc:chgData name="Jonathan Bollig" userId="8b5d0afe-f106-45e0-8c3f-fd98fa124db1" providerId="ADAL" clId="{B108959E-8160-4214-BA0D-42D2F1070C03}" dt="2025-08-17T17:04:25.114" v="2368" actId="20577"/>
-        <pc:sldMkLst>
-          <pc:docMk/>
-          <pc:sldMk cId="3708449378" sldId="264"/>
-        </pc:sldMkLst>
-      </pc:sldChg>
-      <pc:sldChg chg="addSp delSp modSp new mod modNotesTx">
-        <pc:chgData name="Jonathan Bollig" userId="8b5d0afe-f106-45e0-8c3f-fd98fa124db1" providerId="ADAL" clId="{B108959E-8160-4214-BA0D-42D2F1070C03}" dt="2025-08-18T09:38:09.362" v="3531" actId="20577"/>
-        <pc:sldMkLst>
-          <pc:docMk/>
-          <pc:sldMk cId="933916611" sldId="265"/>
-        </pc:sldMkLst>
-      </pc:sldChg>
-      <pc:sldChg chg="modSp new mod ord">
-        <pc:chgData name="Jonathan Bollig" userId="8b5d0afe-f106-45e0-8c3f-fd98fa124db1" providerId="ADAL" clId="{B108959E-8160-4214-BA0D-42D2F1070C03}" dt="2025-08-18T09:21:09.777" v="2944" actId="20577"/>
-        <pc:sldMkLst>
-          <pc:docMk/>
-          <pc:sldMk cId="2117799034" sldId="266"/>
-        </pc:sldMkLst>
-      </pc:sldChg>
-    </pc:docChg>
-  </pc:docChgLst>
-  <pc:docChgLst>
-    <pc:chgData name="Jonathan Bollig" userId="8b5d0afe-f106-45e0-8c3f-fd98fa124db1" providerId="ADAL" clId="{B2469FA9-EBD8-4834-A16D-CBF8EFC907DD}"/>
-    <pc:docChg chg="undo custSel addSld delSld modSld sldOrd">
-      <pc:chgData name="Jonathan Bollig" userId="8b5d0afe-f106-45e0-8c3f-fd98fa124db1" providerId="ADAL" clId="{B2469FA9-EBD8-4834-A16D-CBF8EFC907DD}" dt="2025-10-04T14:10:14.761" v="2676" actId="20577"/>
-      <pc:docMkLst>
-        <pc:docMk/>
-      </pc:docMkLst>
-      <pc:sldChg chg="modSp mod modNotesTx">
-        <pc:chgData name="Jonathan Bollig" userId="8b5d0afe-f106-45e0-8c3f-fd98fa124db1" providerId="ADAL" clId="{B2469FA9-EBD8-4834-A16D-CBF8EFC907DD}" dt="2025-10-04T14:10:14.761" v="2676" actId="20577"/>
-        <pc:sldMkLst>
-          <pc:docMk/>
-          <pc:sldMk cId="836289018" sldId="256"/>
-        </pc:sldMkLst>
-        <pc:spChg chg="mod">
-          <ac:chgData name="Jonathan Bollig" userId="8b5d0afe-f106-45e0-8c3f-fd98fa124db1" providerId="ADAL" clId="{B2469FA9-EBD8-4834-A16D-CBF8EFC907DD}" dt="2025-10-04T14:10:14.761" v="2676" actId="20577"/>
-          <ac:spMkLst>
-            <pc:docMk/>
-            <pc:sldMk cId="836289018" sldId="256"/>
-            <ac:spMk id="2" creationId="{40F72F59-52B3-6063-A2E3-2AA45125A99B}"/>
-          </ac:spMkLst>
-        </pc:spChg>
-      </pc:sldChg>
-      <pc:sldChg chg="add del">
-        <pc:chgData name="Jonathan Bollig" userId="8b5d0afe-f106-45e0-8c3f-fd98fa124db1" providerId="ADAL" clId="{B2469FA9-EBD8-4834-A16D-CBF8EFC907DD}" dt="2025-09-30T13:11:50.306" v="1412" actId="47"/>
-        <pc:sldMkLst>
-          <pc:docMk/>
-          <pc:sldMk cId="2169503629" sldId="259"/>
-        </pc:sldMkLst>
-      </pc:sldChg>
-      <pc:sldChg chg="add del">
-        <pc:chgData name="Jonathan Bollig" userId="8b5d0afe-f106-45e0-8c3f-fd98fa124db1" providerId="ADAL" clId="{B2469FA9-EBD8-4834-A16D-CBF8EFC907DD}" dt="2025-09-30T12:04:33.972" v="134" actId="47"/>
-        <pc:sldMkLst>
-          <pc:docMk/>
-          <pc:sldMk cId="932306145" sldId="260"/>
-        </pc:sldMkLst>
-      </pc:sldChg>
-      <pc:sldChg chg="addSp delSp modSp new add del mod">
-        <pc:chgData name="Jonathan Bollig" userId="8b5d0afe-f106-45e0-8c3f-fd98fa124db1" providerId="ADAL" clId="{B2469FA9-EBD8-4834-A16D-CBF8EFC907DD}" dt="2025-09-29T16:04:28.676" v="59" actId="2696"/>
-        <pc:sldMkLst>
-          <pc:docMk/>
-          <pc:sldMk cId="1788226598" sldId="261"/>
-        </pc:sldMkLst>
-      </pc:sldChg>
-      <pc:sldChg chg="delSp modSp new add del mod">
-        <pc:chgData name="Jonathan Bollig" userId="8b5d0afe-f106-45e0-8c3f-fd98fa124db1" providerId="ADAL" clId="{B2469FA9-EBD8-4834-A16D-CBF8EFC907DD}" dt="2025-09-29T16:04:28.676" v="59" actId="2696"/>
-        <pc:sldMkLst>
-          <pc:docMk/>
-          <pc:sldMk cId="4268657297" sldId="262"/>
-        </pc:sldMkLst>
-      </pc:sldChg>
-      <pc:sldChg chg="del">
-        <pc:chgData name="Jonathan Bollig" userId="8b5d0afe-f106-45e0-8c3f-fd98fa124db1" providerId="ADAL" clId="{B2469FA9-EBD8-4834-A16D-CBF8EFC907DD}" dt="2025-09-29T15:37:05.869" v="0" actId="47"/>
-        <pc:sldMkLst>
-          <pc:docMk/>
-          <pc:sldMk cId="289564934" sldId="265"/>
-        </pc:sldMkLst>
-      </pc:sldChg>
-      <pc:sldChg chg="addSp modSp add mod ord modNotesTx">
-        <pc:chgData name="Jonathan Bollig" userId="8b5d0afe-f106-45e0-8c3f-fd98fa124db1" providerId="ADAL" clId="{B2469FA9-EBD8-4834-A16D-CBF8EFC907DD}" dt="2025-10-01T21:13:28.871" v="2142" actId="20577"/>
-        <pc:sldMkLst>
-          <pc:docMk/>
-          <pc:sldMk cId="1952279139" sldId="269"/>
-        </pc:sldMkLst>
-        <pc:spChg chg="add mod">
-          <ac:chgData name="Jonathan Bollig" userId="8b5d0afe-f106-45e0-8c3f-fd98fa124db1" providerId="ADAL" clId="{B2469FA9-EBD8-4834-A16D-CBF8EFC907DD}" dt="2025-10-01T11:54:51.612" v="1429" actId="5793"/>
-          <ac:spMkLst>
-            <pc:docMk/>
-            <pc:sldMk cId="1952279139" sldId="269"/>
-            <ac:spMk id="4" creationId="{51C6A5DA-6E82-C41B-CB13-F5E6793006A5}"/>
-          </ac:spMkLst>
-        </pc:spChg>
-      </pc:sldChg>
-      <pc:sldChg chg="addSp delSp modSp new mod">
-        <pc:chgData name="Jonathan Bollig" userId="8b5d0afe-f106-45e0-8c3f-fd98fa124db1" providerId="ADAL" clId="{B2469FA9-EBD8-4834-A16D-CBF8EFC907DD}" dt="2025-10-01T15:07:05.539" v="1605" actId="20577"/>
-        <pc:sldMkLst>
-          <pc:docMk/>
-          <pc:sldMk cId="494941062" sldId="270"/>
-        </pc:sldMkLst>
-        <pc:spChg chg="mod">
-          <ac:chgData name="Jonathan Bollig" userId="8b5d0afe-f106-45e0-8c3f-fd98fa124db1" providerId="ADAL" clId="{B2469FA9-EBD8-4834-A16D-CBF8EFC907DD}" dt="2025-09-30T12:03:22.027" v="128" actId="20577"/>
-          <ac:spMkLst>
-            <pc:docMk/>
-            <pc:sldMk cId="494941062" sldId="270"/>
-            <ac:spMk id="2" creationId="{2E33FA72-E98C-300A-2AC3-CB33018D5102}"/>
-          </ac:spMkLst>
-        </pc:spChg>
-        <pc:spChg chg="mod">
-          <ac:chgData name="Jonathan Bollig" userId="8b5d0afe-f106-45e0-8c3f-fd98fa124db1" providerId="ADAL" clId="{B2469FA9-EBD8-4834-A16D-CBF8EFC907DD}" dt="2025-10-01T15:07:05.539" v="1605" actId="20577"/>
-          <ac:spMkLst>
-            <pc:docMk/>
-            <pc:sldMk cId="494941062" sldId="270"/>
-            <ac:spMk id="3" creationId="{03F5C1D7-583E-DCFE-433C-E54A59C50E4B}"/>
-          </ac:spMkLst>
-        </pc:spChg>
-        <pc:picChg chg="add mod">
-          <ac:chgData name="Jonathan Bollig" userId="8b5d0afe-f106-45e0-8c3f-fd98fa124db1" providerId="ADAL" clId="{B2469FA9-EBD8-4834-A16D-CBF8EFC907DD}" dt="2025-09-30T12:07:46.196" v="194" actId="1440"/>
-          <ac:picMkLst>
-            <pc:docMk/>
-            <pc:sldMk cId="494941062" sldId="270"/>
-            <ac:picMk id="5" creationId="{973E4D8F-98E9-F545-A82E-F833A30A3922}"/>
-          </ac:picMkLst>
-        </pc:picChg>
-        <pc:picChg chg="add mod">
-          <ac:chgData name="Jonathan Bollig" userId="8b5d0afe-f106-45e0-8c3f-fd98fa124db1" providerId="ADAL" clId="{B2469FA9-EBD8-4834-A16D-CBF8EFC907DD}" dt="2025-09-30T12:07:49.374" v="195" actId="1076"/>
-          <ac:picMkLst>
-            <pc:docMk/>
-            <pc:sldMk cId="494941062" sldId="270"/>
-            <ac:picMk id="8" creationId="{2EF60FBC-E467-B8D1-2236-450515492354}"/>
-          </ac:picMkLst>
-        </pc:picChg>
-        <pc:picChg chg="add mod">
-          <ac:chgData name="Jonathan Bollig" userId="8b5d0afe-f106-45e0-8c3f-fd98fa124db1" providerId="ADAL" clId="{B2469FA9-EBD8-4834-A16D-CBF8EFC907DD}" dt="2025-09-30T12:07:46.196" v="194" actId="1440"/>
-          <ac:picMkLst>
-            <pc:docMk/>
-            <pc:sldMk cId="494941062" sldId="270"/>
-            <ac:picMk id="10" creationId="{44A07214-53CA-0EB3-30F1-AF0EE527B7D0}"/>
-          </ac:picMkLst>
-        </pc:picChg>
-        <pc:picChg chg="add mod modCrop">
-          <ac:chgData name="Jonathan Bollig" userId="8b5d0afe-f106-45e0-8c3f-fd98fa124db1" providerId="ADAL" clId="{B2469FA9-EBD8-4834-A16D-CBF8EFC907DD}" dt="2025-09-30T12:07:46.196" v="194" actId="1440"/>
-          <ac:picMkLst>
-            <pc:docMk/>
-            <pc:sldMk cId="494941062" sldId="270"/>
-            <ac:picMk id="17" creationId="{62F68DB7-98CA-22B6-91AB-716192CD50D1}"/>
-          </ac:picMkLst>
-        </pc:picChg>
-        <pc:picChg chg="add mod">
-          <ac:chgData name="Jonathan Bollig" userId="8b5d0afe-f106-45e0-8c3f-fd98fa124db1" providerId="ADAL" clId="{B2469FA9-EBD8-4834-A16D-CBF8EFC907DD}" dt="2025-09-30T12:09:25.512" v="232" actId="1440"/>
-          <ac:picMkLst>
-            <pc:docMk/>
-            <pc:sldMk cId="494941062" sldId="270"/>
-            <ac:picMk id="19" creationId="{F0CA82AF-3863-00F5-B622-12B18F659D71}"/>
-          </ac:picMkLst>
-        </pc:picChg>
-        <pc:cxnChg chg="add mod">
-          <ac:chgData name="Jonathan Bollig" userId="8b5d0afe-f106-45e0-8c3f-fd98fa124db1" providerId="ADAL" clId="{B2469FA9-EBD8-4834-A16D-CBF8EFC907DD}" dt="2025-09-30T12:05:06.628" v="156" actId="1076"/>
-          <ac:cxnSpMkLst>
-            <pc:docMk/>
-            <pc:sldMk cId="494941062" sldId="270"/>
-            <ac:cxnSpMk id="6" creationId="{17829158-7E18-F9F8-3145-A5283E123E71}"/>
-          </ac:cxnSpMkLst>
-        </pc:cxnChg>
-        <pc:cxnChg chg="add mod">
-          <ac:chgData name="Jonathan Bollig" userId="8b5d0afe-f106-45e0-8c3f-fd98fa124db1" providerId="ADAL" clId="{B2469FA9-EBD8-4834-A16D-CBF8EFC907DD}" dt="2025-09-30T12:06:59.281" v="183" actId="1076"/>
-          <ac:cxnSpMkLst>
-            <pc:docMk/>
-            <pc:sldMk cId="494941062" sldId="270"/>
-            <ac:cxnSpMk id="13" creationId="{85BD2B1C-B5F1-2A7A-866C-364F34466B49}"/>
-          </ac:cxnSpMkLst>
-        </pc:cxnChg>
-      </pc:sldChg>
-      <pc:sldChg chg="addSp delSp modSp new mod">
-        <pc:chgData name="Jonathan Bollig" userId="8b5d0afe-f106-45e0-8c3f-fd98fa124db1" providerId="ADAL" clId="{B2469FA9-EBD8-4834-A16D-CBF8EFC907DD}" dt="2025-10-01T15:42:39.646" v="1999" actId="1076"/>
-        <pc:sldMkLst>
-          <pc:docMk/>
-          <pc:sldMk cId="4032930627" sldId="271"/>
-        </pc:sldMkLst>
-        <pc:spChg chg="mod">
-          <ac:chgData name="Jonathan Bollig" userId="8b5d0afe-f106-45e0-8c3f-fd98fa124db1" providerId="ADAL" clId="{B2469FA9-EBD8-4834-A16D-CBF8EFC907DD}" dt="2025-09-30T12:11:03.867" v="323" actId="20577"/>
-          <ac:spMkLst>
-            <pc:docMk/>
-            <pc:sldMk cId="4032930627" sldId="271"/>
-            <ac:spMk id="2" creationId="{2523FA2C-2A1D-0A32-B3DF-9D37FE9EB853}"/>
-          </ac:spMkLst>
-        </pc:spChg>
-        <pc:spChg chg="mod">
-          <ac:chgData name="Jonathan Bollig" userId="8b5d0afe-f106-45e0-8c3f-fd98fa124db1" providerId="ADAL" clId="{B2469FA9-EBD8-4834-A16D-CBF8EFC907DD}" dt="2025-09-30T12:11:22.043" v="367" actId="20577"/>
-          <ac:spMkLst>
-            <pc:docMk/>
-            <pc:sldMk cId="4032930627" sldId="271"/>
-            <ac:spMk id="3" creationId="{72EC9643-9C3C-5A5C-2F7E-464DCF9B0D57}"/>
-          </ac:spMkLst>
-        </pc:spChg>
-        <pc:spChg chg="add mod">
-          <ac:chgData name="Jonathan Bollig" userId="8b5d0afe-f106-45e0-8c3f-fd98fa124db1" providerId="ADAL" clId="{B2469FA9-EBD8-4834-A16D-CBF8EFC907DD}" dt="2025-10-01T15:42:09.599" v="1961" actId="13822"/>
-          <ac:spMkLst>
-            <pc:docMk/>
-            <pc:sldMk cId="4032930627" sldId="271"/>
-            <ac:spMk id="4" creationId="{014D8CCE-3557-0CBE-AB35-21F4C588860C}"/>
-          </ac:spMkLst>
-        </pc:spChg>
-        <pc:spChg chg="add mod">
-          <ac:chgData name="Jonathan Bollig" userId="8b5d0afe-f106-45e0-8c3f-fd98fa124db1" providerId="ADAL" clId="{B2469FA9-EBD8-4834-A16D-CBF8EFC907DD}" dt="2025-10-01T15:42:39.646" v="1999" actId="1076"/>
-          <ac:spMkLst>
-            <pc:docMk/>
-            <pc:sldMk cId="4032930627" sldId="271"/>
-            <ac:spMk id="6" creationId="{5019B27F-4D5B-57F9-9DCB-2940D4BD737D}"/>
-          </ac:spMkLst>
-        </pc:spChg>
-        <pc:spChg chg="add mod">
-          <ac:chgData name="Jonathan Bollig" userId="8b5d0afe-f106-45e0-8c3f-fd98fa124db1" providerId="ADAL" clId="{B2469FA9-EBD8-4834-A16D-CBF8EFC907DD}" dt="2025-09-30T12:34:12.542" v="865" actId="1076"/>
-          <ac:spMkLst>
-            <pc:docMk/>
-            <pc:sldMk cId="4032930627" sldId="271"/>
-            <ac:spMk id="13" creationId="{18011108-EAE4-A275-0A16-B642D40704D3}"/>
-          </ac:spMkLst>
-        </pc:spChg>
-        <pc:picChg chg="add mod">
-          <ac:chgData name="Jonathan Bollig" userId="8b5d0afe-f106-45e0-8c3f-fd98fa124db1" providerId="ADAL" clId="{B2469FA9-EBD8-4834-A16D-CBF8EFC907DD}" dt="2025-09-30T12:10:32.449" v="276" actId="1076"/>
-          <ac:picMkLst>
-            <pc:docMk/>
-            <pc:sldMk cId="4032930627" sldId="271"/>
-            <ac:picMk id="5" creationId="{AC5B6BAB-2627-83B4-3B7C-C374C2F1677D}"/>
-          </ac:picMkLst>
-        </pc:picChg>
-        <pc:picChg chg="add mod">
-          <ac:chgData name="Jonathan Bollig" userId="8b5d0afe-f106-45e0-8c3f-fd98fa124db1" providerId="ADAL" clId="{B2469FA9-EBD8-4834-A16D-CBF8EFC907DD}" dt="2025-09-30T12:10:56.850" v="279" actId="14100"/>
-          <ac:picMkLst>
-            <pc:docMk/>
-            <pc:sldMk cId="4032930627" sldId="271"/>
-            <ac:picMk id="7" creationId="{4EAA1E3F-A672-06FA-F90D-C8E737F9689C}"/>
-          </ac:picMkLst>
-        </pc:picChg>
-        <pc:picChg chg="add mod modCrop">
-          <ac:chgData name="Jonathan Bollig" userId="8b5d0afe-f106-45e0-8c3f-fd98fa124db1" providerId="ADAL" clId="{B2469FA9-EBD8-4834-A16D-CBF8EFC907DD}" dt="2025-09-30T12:14:12.087" v="380" actId="1076"/>
-          <ac:picMkLst>
-            <pc:docMk/>
-            <pc:sldMk cId="4032930627" sldId="271"/>
-            <ac:picMk id="11" creationId="{FA55AD83-437D-21F3-EE34-60617C9ECFA7}"/>
-          </ac:picMkLst>
-        </pc:picChg>
-        <pc:picChg chg="add mod modCrop">
-          <ac:chgData name="Jonathan Bollig" userId="8b5d0afe-f106-45e0-8c3f-fd98fa124db1" providerId="ADAL" clId="{B2469FA9-EBD8-4834-A16D-CBF8EFC907DD}" dt="2025-09-30T12:14:19.685" v="381" actId="1076"/>
-          <ac:picMkLst>
-            <pc:docMk/>
-            <pc:sldMk cId="4032930627" sldId="271"/>
-            <ac:picMk id="12" creationId="{8D9C6C91-3EC3-D5DD-291A-A87AEFC30B71}"/>
-          </ac:picMkLst>
-        </pc:picChg>
-      </pc:sldChg>
-      <pc:sldChg chg="addSp delSp modSp new mod">
-        <pc:chgData name="Jonathan Bollig" userId="8b5d0afe-f106-45e0-8c3f-fd98fa124db1" providerId="ADAL" clId="{B2469FA9-EBD8-4834-A16D-CBF8EFC907DD}" dt="2025-10-01T21:11:57.865" v="2087" actId="14100"/>
-        <pc:sldMkLst>
-          <pc:docMk/>
-          <pc:sldMk cId="3145733069" sldId="272"/>
-        </pc:sldMkLst>
-        <pc:spChg chg="add mod">
-          <ac:chgData name="Jonathan Bollig" userId="8b5d0afe-f106-45e0-8c3f-fd98fa124db1" providerId="ADAL" clId="{B2469FA9-EBD8-4834-A16D-CBF8EFC907DD}" dt="2025-10-01T21:11:44.193" v="2082" actId="20577"/>
-          <ac:spMkLst>
-            <pc:docMk/>
-            <pc:sldMk cId="3145733069" sldId="272"/>
-            <ac:spMk id="2" creationId="{5A57062A-3CE9-DEAD-81E9-14CF7F46DA7B}"/>
-          </ac:spMkLst>
-        </pc:spChg>
-        <pc:spChg chg="add mod">
-          <ac:chgData name="Jonathan Bollig" userId="8b5d0afe-f106-45e0-8c3f-fd98fa124db1" providerId="ADAL" clId="{B2469FA9-EBD8-4834-A16D-CBF8EFC907DD}" dt="2025-09-30T12:16:48.377" v="388"/>
-          <ac:spMkLst>
-            <pc:docMk/>
-            <pc:sldMk cId="3145733069" sldId="272"/>
-            <ac:spMk id="7" creationId="{C13A6555-531A-2ADA-D647-0D9459D986DB}"/>
-          </ac:spMkLst>
-        </pc:spChg>
-        <pc:picChg chg="add mod">
-          <ac:chgData name="Jonathan Bollig" userId="8b5d0afe-f106-45e0-8c3f-fd98fa124db1" providerId="ADAL" clId="{B2469FA9-EBD8-4834-A16D-CBF8EFC907DD}" dt="2025-09-30T12:16:48.377" v="388"/>
-          <ac:picMkLst>
-            <pc:docMk/>
-            <pc:sldMk cId="3145733069" sldId="272"/>
-            <ac:picMk id="8" creationId="{90B7E8AE-A8A2-7DBA-F29C-3C4149CC9C06}"/>
-          </ac:picMkLst>
-        </pc:picChg>
-        <pc:picChg chg="add mod">
-          <ac:chgData name="Jonathan Bollig" userId="8b5d0afe-f106-45e0-8c3f-fd98fa124db1" providerId="ADAL" clId="{B2469FA9-EBD8-4834-A16D-CBF8EFC907DD}" dt="2025-09-30T12:16:48.377" v="388"/>
-          <ac:picMkLst>
-            <pc:docMk/>
-            <pc:sldMk cId="3145733069" sldId="272"/>
-            <ac:picMk id="9" creationId="{B3B670D8-3095-CF2A-CED3-F23ACBDFBE14}"/>
-          </ac:picMkLst>
-        </pc:picChg>
-        <pc:picChg chg="add mod">
-          <ac:chgData name="Jonathan Bollig" userId="8b5d0afe-f106-45e0-8c3f-fd98fa124db1" providerId="ADAL" clId="{B2469FA9-EBD8-4834-A16D-CBF8EFC907DD}" dt="2025-09-30T12:17:56.012" v="397" actId="1440"/>
-          <ac:picMkLst>
-            <pc:docMk/>
-            <pc:sldMk cId="3145733069" sldId="272"/>
-            <ac:picMk id="11" creationId="{707189CF-54D6-3E43-336F-62F68078FB1E}"/>
-          </ac:picMkLst>
-        </pc:picChg>
-        <pc:picChg chg="add mod">
-          <ac:chgData name="Jonathan Bollig" userId="8b5d0afe-f106-45e0-8c3f-fd98fa124db1" providerId="ADAL" clId="{B2469FA9-EBD8-4834-A16D-CBF8EFC907DD}" dt="2025-09-30T12:17:56.012" v="397" actId="1440"/>
-          <ac:picMkLst>
-            <pc:docMk/>
-            <pc:sldMk cId="3145733069" sldId="272"/>
-            <ac:picMk id="13" creationId="{63D40F3F-9141-19C2-B96B-B80FB58857CF}"/>
-          </ac:picMkLst>
-        </pc:picChg>
-        <pc:cxnChg chg="add mod">
-          <ac:chgData name="Jonathan Bollig" userId="8b5d0afe-f106-45e0-8c3f-fd98fa124db1" providerId="ADAL" clId="{B2469FA9-EBD8-4834-A16D-CBF8EFC907DD}" dt="2025-10-01T21:11:57.865" v="2087" actId="14100"/>
-          <ac:cxnSpMkLst>
-            <pc:docMk/>
-            <pc:sldMk cId="3145733069" sldId="272"/>
-            <ac:cxnSpMk id="3" creationId="{8A84E87D-EFB4-D2C4-8A5D-BACE775DE691}"/>
-          </ac:cxnSpMkLst>
-        </pc:cxnChg>
-        <pc:cxnChg chg="add mod">
-          <ac:chgData name="Jonathan Bollig" userId="8b5d0afe-f106-45e0-8c3f-fd98fa124db1" providerId="ADAL" clId="{B2469FA9-EBD8-4834-A16D-CBF8EFC907DD}" dt="2025-09-30T12:17:51.546" v="396" actId="1076"/>
-          <ac:cxnSpMkLst>
-            <pc:docMk/>
-            <pc:sldMk cId="3145733069" sldId="272"/>
-            <ac:cxnSpMk id="14" creationId="{F296950F-44D0-7F1A-EC74-A8685185796D}"/>
-          </ac:cxnSpMkLst>
-        </pc:cxnChg>
-      </pc:sldChg>
-      <pc:sldChg chg="addSp delSp modSp new mod modNotesTx">
-        <pc:chgData name="Jonathan Bollig" userId="8b5d0afe-f106-45e0-8c3f-fd98fa124db1" providerId="ADAL" clId="{B2469FA9-EBD8-4834-A16D-CBF8EFC907DD}" dt="2025-10-01T23:41:36.681" v="2566" actId="20577"/>
-        <pc:sldMkLst>
-          <pc:docMk/>
-          <pc:sldMk cId="404308816" sldId="273"/>
-        </pc:sldMkLst>
-        <pc:spChg chg="mod">
-          <ac:chgData name="Jonathan Bollig" userId="8b5d0afe-f106-45e0-8c3f-fd98fa124db1" providerId="ADAL" clId="{B2469FA9-EBD8-4834-A16D-CBF8EFC907DD}" dt="2025-09-30T12:30:56.267" v="632" actId="20577"/>
-          <ac:spMkLst>
-            <pc:docMk/>
-            <pc:sldMk cId="404308816" sldId="273"/>
-            <ac:spMk id="2" creationId="{15323CD0-6A66-DAFE-2D83-296D82F2A232}"/>
-          </ac:spMkLst>
-        </pc:spChg>
-        <pc:spChg chg="mod">
-          <ac:chgData name="Jonathan Bollig" userId="8b5d0afe-f106-45e0-8c3f-fd98fa124db1" providerId="ADAL" clId="{B2469FA9-EBD8-4834-A16D-CBF8EFC907DD}" dt="2025-09-30T12:38:33.012" v="950" actId="20577"/>
-          <ac:spMkLst>
-            <pc:docMk/>
-            <pc:sldMk cId="404308816" sldId="273"/>
-            <ac:spMk id="3" creationId="{3F24F9F5-277C-D386-EF5E-76BB60B6D526}"/>
-          </ac:spMkLst>
-        </pc:spChg>
-        <pc:spChg chg="add mod">
-          <ac:chgData name="Jonathan Bollig" userId="8b5d0afe-f106-45e0-8c3f-fd98fa124db1" providerId="ADAL" clId="{B2469FA9-EBD8-4834-A16D-CBF8EFC907DD}" dt="2025-09-30T12:38:44.925" v="951" actId="1076"/>
-          <ac:spMkLst>
-            <pc:docMk/>
-            <pc:sldMk cId="404308816" sldId="273"/>
-            <ac:spMk id="16" creationId="{CB1FD1BF-A8F0-645C-E782-CF6E6B4833BA}"/>
-          </ac:spMkLst>
-        </pc:spChg>
-        <pc:spChg chg="add mod">
-          <ac:chgData name="Jonathan Bollig" userId="8b5d0afe-f106-45e0-8c3f-fd98fa124db1" providerId="ADAL" clId="{B2469FA9-EBD8-4834-A16D-CBF8EFC907DD}" dt="2025-09-30T12:39:48.192" v="963" actId="1076"/>
-          <ac:spMkLst>
-            <pc:docMk/>
-            <pc:sldMk cId="404308816" sldId="273"/>
-            <ac:spMk id="19" creationId="{FD560D27-8F6A-ADFF-CF9D-8203C7C98CF3}"/>
-          </ac:spMkLst>
-        </pc:spChg>
-        <pc:picChg chg="add mod">
-          <ac:chgData name="Jonathan Bollig" userId="8b5d0afe-f106-45e0-8c3f-fd98fa124db1" providerId="ADAL" clId="{B2469FA9-EBD8-4834-A16D-CBF8EFC907DD}" dt="2025-10-01T15:41:26.627" v="1959" actId="1440"/>
-          <ac:picMkLst>
-            <pc:docMk/>
-            <pc:sldMk cId="404308816" sldId="273"/>
-            <ac:picMk id="5" creationId="{E6FDE3D5-76BF-9092-53D9-6449BC060902}"/>
-          </ac:picMkLst>
-        </pc:picChg>
-        <pc:picChg chg="add mod">
-          <ac:chgData name="Jonathan Bollig" userId="8b5d0afe-f106-45e0-8c3f-fd98fa124db1" providerId="ADAL" clId="{B2469FA9-EBD8-4834-A16D-CBF8EFC907DD}" dt="2025-09-30T12:33:46.898" v="858" actId="1076"/>
-          <ac:picMkLst>
-            <pc:docMk/>
-            <pc:sldMk cId="404308816" sldId="273"/>
-            <ac:picMk id="9" creationId="{2FDB8572-E43F-CF8C-8128-E8A49F7958AA}"/>
-          </ac:picMkLst>
-        </pc:picChg>
-        <pc:picChg chg="add mod">
-          <ac:chgData name="Jonathan Bollig" userId="8b5d0afe-f106-45e0-8c3f-fd98fa124db1" providerId="ADAL" clId="{B2469FA9-EBD8-4834-A16D-CBF8EFC907DD}" dt="2025-09-30T12:33:50.244" v="859" actId="1076"/>
-          <ac:picMkLst>
-            <pc:docMk/>
-            <pc:sldMk cId="404308816" sldId="273"/>
-            <ac:picMk id="11" creationId="{48CDDF7D-125F-AE61-5658-F841A7D783AD}"/>
-          </ac:picMkLst>
-        </pc:picChg>
-        <pc:picChg chg="add mod">
-          <ac:chgData name="Jonathan Bollig" userId="8b5d0afe-f106-45e0-8c3f-fd98fa124db1" providerId="ADAL" clId="{B2469FA9-EBD8-4834-A16D-CBF8EFC907DD}" dt="2025-09-30T12:39:14.763" v="955" actId="1440"/>
-          <ac:picMkLst>
-            <pc:docMk/>
-            <pc:sldMk cId="404308816" sldId="273"/>
-            <ac:picMk id="15" creationId="{108D46A4-E8F4-928C-E57A-5F067EF29D92}"/>
-          </ac:picMkLst>
-        </pc:picChg>
-        <pc:picChg chg="add mod">
-          <ac:chgData name="Jonathan Bollig" userId="8b5d0afe-f106-45e0-8c3f-fd98fa124db1" providerId="ADAL" clId="{B2469FA9-EBD8-4834-A16D-CBF8EFC907DD}" dt="2025-09-30T12:39:38.670" v="960" actId="1076"/>
-          <ac:picMkLst>
-            <pc:docMk/>
-            <pc:sldMk cId="404308816" sldId="273"/>
-            <ac:picMk id="18" creationId="{664B0FEC-8D8F-63DB-A641-8B184DD7E370}"/>
-          </ac:picMkLst>
-        </pc:picChg>
-        <pc:cxnChg chg="add mod">
-          <ac:chgData name="Jonathan Bollig" userId="8b5d0afe-f106-45e0-8c3f-fd98fa124db1" providerId="ADAL" clId="{B2469FA9-EBD8-4834-A16D-CBF8EFC907DD}" dt="2025-09-30T12:33:44.461" v="857" actId="1076"/>
-          <ac:cxnSpMkLst>
-            <pc:docMk/>
-            <pc:sldMk cId="404308816" sldId="273"/>
-            <ac:cxnSpMk id="12" creationId="{16E7E81C-8B62-E75D-E4A1-4C93705885B1}"/>
-          </ac:cxnSpMkLst>
-        </pc:cxnChg>
-        <pc:cxnChg chg="add mod">
-          <ac:chgData name="Jonathan Bollig" userId="8b5d0afe-f106-45e0-8c3f-fd98fa124db1" providerId="ADAL" clId="{B2469FA9-EBD8-4834-A16D-CBF8EFC907DD}" dt="2025-09-30T12:33:42.170" v="856" actId="1076"/>
-          <ac:cxnSpMkLst>
-            <pc:docMk/>
-            <pc:sldMk cId="404308816" sldId="273"/>
-            <ac:cxnSpMk id="13" creationId="{405101E5-3ED3-C2A7-C027-1F8B4B27EB14}"/>
-          </ac:cxnSpMkLst>
-        </pc:cxnChg>
-      </pc:sldChg>
-      <pc:sldChg chg="addSp modSp new mod modNotesTx">
-        <pc:chgData name="Jonathan Bollig" userId="8b5d0afe-f106-45e0-8c3f-fd98fa124db1" providerId="ADAL" clId="{B2469FA9-EBD8-4834-A16D-CBF8EFC907DD}" dt="2025-10-01T23:00:37.205" v="2259" actId="20577"/>
-        <pc:sldMkLst>
-          <pc:docMk/>
-          <pc:sldMk cId="4148233273" sldId="274"/>
-        </pc:sldMkLst>
-        <pc:spChg chg="mod">
-          <ac:chgData name="Jonathan Bollig" userId="8b5d0afe-f106-45e0-8c3f-fd98fa124db1" providerId="ADAL" clId="{B2469FA9-EBD8-4834-A16D-CBF8EFC907DD}" dt="2025-10-01T22:56:45.813" v="2160" actId="20577"/>
-          <ac:spMkLst>
-            <pc:docMk/>
-            <pc:sldMk cId="4148233273" sldId="274"/>
-            <ac:spMk id="2" creationId="{B3CBD481-0074-09AF-8B7C-16F8D706B937}"/>
-          </ac:spMkLst>
-        </pc:spChg>
-        <pc:spChg chg="mod">
-          <ac:chgData name="Jonathan Bollig" userId="8b5d0afe-f106-45e0-8c3f-fd98fa124db1" providerId="ADAL" clId="{B2469FA9-EBD8-4834-A16D-CBF8EFC907DD}" dt="2025-10-01T22:57:13.325" v="2201" actId="20577"/>
-          <ac:spMkLst>
-            <pc:docMk/>
-            <pc:sldMk cId="4148233273" sldId="274"/>
-            <ac:spMk id="3" creationId="{505D3317-ECEE-3E57-39B7-BD06280FCCD7}"/>
-          </ac:spMkLst>
-        </pc:spChg>
-        <pc:picChg chg="add mod">
-          <ac:chgData name="Jonathan Bollig" userId="8b5d0afe-f106-45e0-8c3f-fd98fa124db1" providerId="ADAL" clId="{B2469FA9-EBD8-4834-A16D-CBF8EFC907DD}" dt="2025-10-01T22:57:16.788" v="2202" actId="1076"/>
-          <ac:picMkLst>
-            <pc:docMk/>
-            <pc:sldMk cId="4148233273" sldId="274"/>
-            <ac:picMk id="5" creationId="{8B422CF8-67CD-D647-62EB-765EE67FC5CD}"/>
-          </ac:picMkLst>
-        </pc:picChg>
-        <pc:picChg chg="add mod">
-          <ac:chgData name="Jonathan Bollig" userId="8b5d0afe-f106-45e0-8c3f-fd98fa124db1" providerId="ADAL" clId="{B2469FA9-EBD8-4834-A16D-CBF8EFC907DD}" dt="2025-10-01T23:00:24.521" v="2210" actId="1076"/>
-          <ac:picMkLst>
-            <pc:docMk/>
-            <pc:sldMk cId="4148233273" sldId="274"/>
-            <ac:picMk id="6" creationId="{93AE58E7-5EDC-B6BF-969B-2A5F5E68E7C5}"/>
-          </ac:picMkLst>
-        </pc:picChg>
-        <pc:picChg chg="add mod">
-          <ac:chgData name="Jonathan Bollig" userId="8b5d0afe-f106-45e0-8c3f-fd98fa124db1" providerId="ADAL" clId="{B2469FA9-EBD8-4834-A16D-CBF8EFC907DD}" dt="2025-10-01T22:57:23.671" v="2205" actId="1076"/>
-          <ac:picMkLst>
-            <pc:docMk/>
-            <pc:sldMk cId="4148233273" sldId="274"/>
-            <ac:picMk id="7" creationId="{D9149754-45B3-C001-976F-A39BDAFE3708}"/>
-          </ac:picMkLst>
-        </pc:picChg>
-        <pc:picChg chg="add mod">
-          <ac:chgData name="Jonathan Bollig" userId="8b5d0afe-f106-45e0-8c3f-fd98fa124db1" providerId="ADAL" clId="{B2469FA9-EBD8-4834-A16D-CBF8EFC907DD}" dt="2025-10-01T22:57:21.108" v="2204" actId="1076"/>
-          <ac:picMkLst>
-            <pc:docMk/>
-            <pc:sldMk cId="4148233273" sldId="274"/>
-            <ac:picMk id="9" creationId="{3704010C-3AFB-4981-979E-99EA1D5B8946}"/>
-          </ac:picMkLst>
-        </pc:picChg>
-      </pc:sldChg>
-      <pc:sldChg chg="addSp modSp new mod">
-        <pc:chgData name="Jonathan Bollig" userId="8b5d0afe-f106-45e0-8c3f-fd98fa124db1" providerId="ADAL" clId="{B2469FA9-EBD8-4834-A16D-CBF8EFC907DD}" dt="2025-09-30T13:00:42.933" v="1139" actId="14100"/>
-        <pc:sldMkLst>
-          <pc:docMk/>
-          <pc:sldMk cId="4261150730" sldId="275"/>
-        </pc:sldMkLst>
-        <pc:spChg chg="mod">
-          <ac:chgData name="Jonathan Bollig" userId="8b5d0afe-f106-45e0-8c3f-fd98fa124db1" providerId="ADAL" clId="{B2469FA9-EBD8-4834-A16D-CBF8EFC907DD}" dt="2025-09-30T13:00:21.559" v="1134" actId="20577"/>
-          <ac:spMkLst>
-            <pc:docMk/>
-            <pc:sldMk cId="4261150730" sldId="275"/>
-            <ac:spMk id="2" creationId="{736B112D-0CCE-4420-5959-5817AA3E3739}"/>
-          </ac:spMkLst>
-        </pc:spChg>
-        <pc:picChg chg="add mod">
-          <ac:chgData name="Jonathan Bollig" userId="8b5d0afe-f106-45e0-8c3f-fd98fa124db1" providerId="ADAL" clId="{B2469FA9-EBD8-4834-A16D-CBF8EFC907DD}" dt="2025-09-30T13:00:42.933" v="1139" actId="14100"/>
-          <ac:picMkLst>
-            <pc:docMk/>
-            <pc:sldMk cId="4261150730" sldId="275"/>
-            <ac:picMk id="5" creationId="{7BE6B2F9-D324-C0BF-D945-D905F54A9EFA}"/>
-          </ac:picMkLst>
-        </pc:picChg>
-      </pc:sldChg>
-      <pc:sldChg chg="addSp modSp new mod">
-        <pc:chgData name="Jonathan Bollig" userId="8b5d0afe-f106-45e0-8c3f-fd98fa124db1" providerId="ADAL" clId="{B2469FA9-EBD8-4834-A16D-CBF8EFC907DD}" dt="2025-10-01T23:42:12.950" v="2567" actId="20577"/>
-        <pc:sldMkLst>
-          <pc:docMk/>
-          <pc:sldMk cId="3364527873" sldId="276"/>
-        </pc:sldMkLst>
-        <pc:spChg chg="mod">
-          <ac:chgData name="Jonathan Bollig" userId="8b5d0afe-f106-45e0-8c3f-fd98fa124db1" providerId="ADAL" clId="{B2469FA9-EBD8-4834-A16D-CBF8EFC907DD}" dt="2025-09-30T13:01:46.155" v="1192" actId="20577"/>
-          <ac:spMkLst>
-            <pc:docMk/>
-            <pc:sldMk cId="3364527873" sldId="276"/>
-            <ac:spMk id="2" creationId="{A79B6E5F-7D74-E045-EAB9-5858784DC148}"/>
-          </ac:spMkLst>
-        </pc:spChg>
-        <pc:spChg chg="mod">
-          <ac:chgData name="Jonathan Bollig" userId="8b5d0afe-f106-45e0-8c3f-fd98fa124db1" providerId="ADAL" clId="{B2469FA9-EBD8-4834-A16D-CBF8EFC907DD}" dt="2025-10-01T23:42:12.950" v="2567" actId="20577"/>
-          <ac:spMkLst>
-            <pc:docMk/>
-            <pc:sldMk cId="3364527873" sldId="276"/>
-            <ac:spMk id="3" creationId="{EC1A6E1C-7C3C-E266-7519-55CC4030AA94}"/>
-          </ac:spMkLst>
-        </pc:spChg>
-        <pc:picChg chg="add mod">
-          <ac:chgData name="Jonathan Bollig" userId="8b5d0afe-f106-45e0-8c3f-fd98fa124db1" providerId="ADAL" clId="{B2469FA9-EBD8-4834-A16D-CBF8EFC907DD}" dt="2025-09-30T13:04:18.891" v="1278" actId="1440"/>
-          <ac:picMkLst>
-            <pc:docMk/>
-            <pc:sldMk cId="3364527873" sldId="276"/>
-            <ac:picMk id="5" creationId="{99C8EEEE-A2D0-37F4-0A28-92F84A23B0A6}"/>
-          </ac:picMkLst>
-        </pc:picChg>
-        <pc:picChg chg="add mod">
-          <ac:chgData name="Jonathan Bollig" userId="8b5d0afe-f106-45e0-8c3f-fd98fa124db1" providerId="ADAL" clId="{B2469FA9-EBD8-4834-A16D-CBF8EFC907DD}" dt="2025-09-30T13:04:18.891" v="1278" actId="1440"/>
-          <ac:picMkLst>
-            <pc:docMk/>
-            <pc:sldMk cId="3364527873" sldId="276"/>
-            <ac:picMk id="7" creationId="{2FA8B062-956B-D5D7-3B46-5395C6E7B691}"/>
-          </ac:picMkLst>
-        </pc:picChg>
-        <pc:picChg chg="add mod">
-          <ac:chgData name="Jonathan Bollig" userId="8b5d0afe-f106-45e0-8c3f-fd98fa124db1" providerId="ADAL" clId="{B2469FA9-EBD8-4834-A16D-CBF8EFC907DD}" dt="2025-09-30T13:04:30.579" v="1281" actId="1076"/>
-          <ac:picMkLst>
-            <pc:docMk/>
-            <pc:sldMk cId="3364527873" sldId="276"/>
-            <ac:picMk id="9" creationId="{463BC8E6-B85D-AD0F-6DCA-06FC1E7AA66B}"/>
-          </ac:picMkLst>
-        </pc:picChg>
-        <pc:cxnChg chg="add mod">
-          <ac:chgData name="Jonathan Bollig" userId="8b5d0afe-f106-45e0-8c3f-fd98fa124db1" providerId="ADAL" clId="{B2469FA9-EBD8-4834-A16D-CBF8EFC907DD}" dt="2025-09-30T13:04:32.439" v="1282" actId="1076"/>
-          <ac:cxnSpMkLst>
-            <pc:docMk/>
-            <pc:sldMk cId="3364527873" sldId="276"/>
-            <ac:cxnSpMk id="10" creationId="{3E676E71-ADC7-23ED-A200-449B2EAFE0DD}"/>
-          </ac:cxnSpMkLst>
-        </pc:cxnChg>
-      </pc:sldChg>
-      <pc:sldChg chg="addSp delSp modSp add mod">
-        <pc:chgData name="Jonathan Bollig" userId="8b5d0afe-f106-45e0-8c3f-fd98fa124db1" providerId="ADAL" clId="{B2469FA9-EBD8-4834-A16D-CBF8EFC907DD}" dt="2025-10-01T23:44:32.962" v="2650" actId="1440"/>
-        <pc:sldMkLst>
-          <pc:docMk/>
-          <pc:sldMk cId="630764663" sldId="277"/>
-        </pc:sldMkLst>
-        <pc:spChg chg="mod">
-          <ac:chgData name="Jonathan Bollig" userId="8b5d0afe-f106-45e0-8c3f-fd98fa124db1" providerId="ADAL" clId="{B2469FA9-EBD8-4834-A16D-CBF8EFC907DD}" dt="2025-10-01T23:44:17.447" v="2644" actId="20577"/>
-          <ac:spMkLst>
-            <pc:docMk/>
-            <pc:sldMk cId="630764663" sldId="277"/>
-            <ac:spMk id="2" creationId="{8DF4BF10-4960-9DA4-6B87-92E098291ECC}"/>
-          </ac:spMkLst>
-        </pc:spChg>
-        <pc:spChg chg="mod">
-          <ac:chgData name="Jonathan Bollig" userId="8b5d0afe-f106-45e0-8c3f-fd98fa124db1" providerId="ADAL" clId="{B2469FA9-EBD8-4834-A16D-CBF8EFC907DD}" dt="2025-10-01T23:43:18.496" v="2627" actId="20577"/>
-          <ac:spMkLst>
-            <pc:docMk/>
-            <pc:sldMk cId="630764663" sldId="277"/>
-            <ac:spMk id="3" creationId="{17B64C34-38FE-5E3C-B01E-93CF0D89469D}"/>
-          </ac:spMkLst>
-        </pc:spChg>
-        <pc:picChg chg="add mod">
-          <ac:chgData name="Jonathan Bollig" userId="8b5d0afe-f106-45e0-8c3f-fd98fa124db1" providerId="ADAL" clId="{B2469FA9-EBD8-4834-A16D-CBF8EFC907DD}" dt="2025-10-01T23:44:32.962" v="2650" actId="1440"/>
-          <ac:picMkLst>
-            <pc:docMk/>
-            <pc:sldMk cId="630764663" sldId="277"/>
-            <ac:picMk id="5" creationId="{0F70CD7B-DE89-6198-1DC4-FAF3A54576EC}"/>
-          </ac:picMkLst>
-        </pc:picChg>
-        <pc:picChg chg="add mod">
-          <ac:chgData name="Jonathan Bollig" userId="8b5d0afe-f106-45e0-8c3f-fd98fa124db1" providerId="ADAL" clId="{B2469FA9-EBD8-4834-A16D-CBF8EFC907DD}" dt="2025-10-01T23:44:29.468" v="2648" actId="14100"/>
-          <ac:picMkLst>
-            <pc:docMk/>
-            <pc:sldMk cId="630764663" sldId="277"/>
-            <ac:picMk id="11" creationId="{29FB3A71-CC1C-240E-C809-7A5A5F8EB4B0}"/>
-          </ac:picMkLst>
-        </pc:picChg>
-        <pc:picChg chg="add mod">
-          <ac:chgData name="Jonathan Bollig" userId="8b5d0afe-f106-45e0-8c3f-fd98fa124db1" providerId="ADAL" clId="{B2469FA9-EBD8-4834-A16D-CBF8EFC907DD}" dt="2025-10-01T23:42:58.133" v="2574" actId="14100"/>
-          <ac:picMkLst>
-            <pc:docMk/>
-            <pc:sldMk cId="630764663" sldId="277"/>
-            <ac:picMk id="13" creationId="{C1EA46B8-E8EE-02F3-08AA-12ABDFF22BB8}"/>
-          </ac:picMkLst>
-        </pc:picChg>
-      </pc:sldChg>
-      <pc:sldChg chg="addSp modSp new mod">
-        <pc:chgData name="Jonathan Bollig" userId="8b5d0afe-f106-45e0-8c3f-fd98fa124db1" providerId="ADAL" clId="{B2469FA9-EBD8-4834-A16D-CBF8EFC907DD}" dt="2025-10-04T11:23:03.057" v="2674" actId="1440"/>
-        <pc:sldMkLst>
-          <pc:docMk/>
-          <pc:sldMk cId="3556157686" sldId="278"/>
-        </pc:sldMkLst>
-        <pc:spChg chg="mod">
-          <ac:chgData name="Jonathan Bollig" userId="8b5d0afe-f106-45e0-8c3f-fd98fa124db1" providerId="ADAL" clId="{B2469FA9-EBD8-4834-A16D-CBF8EFC907DD}" dt="2025-10-01T15:07:13.770" v="1630" actId="20577"/>
-          <ac:spMkLst>
-            <pc:docMk/>
-            <pc:sldMk cId="3556157686" sldId="278"/>
-            <ac:spMk id="2" creationId="{0B15C6DA-8658-35A8-8036-BC17ED41BAD9}"/>
-          </ac:spMkLst>
-        </pc:spChg>
-        <pc:spChg chg="mod">
-          <ac:chgData name="Jonathan Bollig" userId="8b5d0afe-f106-45e0-8c3f-fd98fa124db1" providerId="ADAL" clId="{B2469FA9-EBD8-4834-A16D-CBF8EFC907DD}" dt="2025-10-04T11:22:52.092" v="2670" actId="20577"/>
-          <ac:spMkLst>
-            <pc:docMk/>
-            <pc:sldMk cId="3556157686" sldId="278"/>
-            <ac:spMk id="3" creationId="{DA31BAF5-437E-68D6-B42E-36B45D761FCB}"/>
-          </ac:spMkLst>
-        </pc:spChg>
-        <pc:picChg chg="add mod">
-          <ac:chgData name="Jonathan Bollig" userId="8b5d0afe-f106-45e0-8c3f-fd98fa124db1" providerId="ADAL" clId="{B2469FA9-EBD8-4834-A16D-CBF8EFC907DD}" dt="2025-10-04T11:23:03.057" v="2674" actId="1440"/>
-          <ac:picMkLst>
-            <pc:docMk/>
-            <pc:sldMk cId="3556157686" sldId="278"/>
-            <ac:picMk id="5" creationId="{DB03AE92-1B35-949C-E7A0-D8E727DB0D2C}"/>
-          </ac:picMkLst>
-        </pc:picChg>
-      </pc:sldChg>
-      <pc:sldChg chg="addSp modSp new mod">
-        <pc:chgData name="Jonathan Bollig" userId="8b5d0afe-f106-45e0-8c3f-fd98fa124db1" providerId="ADAL" clId="{B2469FA9-EBD8-4834-A16D-CBF8EFC907DD}" dt="2025-10-01T23:38:46.358" v="2538" actId="20577"/>
-        <pc:sldMkLst>
-          <pc:docMk/>
-          <pc:sldMk cId="314853837" sldId="279"/>
-        </pc:sldMkLst>
-        <pc:spChg chg="mod">
-          <ac:chgData name="Jonathan Bollig" userId="8b5d0afe-f106-45e0-8c3f-fd98fa124db1" providerId="ADAL" clId="{B2469FA9-EBD8-4834-A16D-CBF8EFC907DD}" dt="2025-10-01T23:33:21.552" v="2294" actId="20577"/>
-          <ac:spMkLst>
-            <pc:docMk/>
-            <pc:sldMk cId="314853837" sldId="279"/>
-            <ac:spMk id="2" creationId="{6F634ECE-57DB-0DAB-8188-E06DF59A9237}"/>
-          </ac:spMkLst>
-        </pc:spChg>
-        <pc:spChg chg="mod">
-          <ac:chgData name="Jonathan Bollig" userId="8b5d0afe-f106-45e0-8c3f-fd98fa124db1" providerId="ADAL" clId="{B2469FA9-EBD8-4834-A16D-CBF8EFC907DD}" dt="2025-10-01T23:38:46.358" v="2538" actId="20577"/>
-          <ac:spMkLst>
-            <pc:docMk/>
-            <pc:sldMk cId="314853837" sldId="279"/>
-            <ac:spMk id="3" creationId="{E3595D40-B969-9669-C8D5-764502F8C3A6}"/>
-          </ac:spMkLst>
-        </pc:spChg>
-        <pc:picChg chg="add mod">
-          <ac:chgData name="Jonathan Bollig" userId="8b5d0afe-f106-45e0-8c3f-fd98fa124db1" providerId="ADAL" clId="{B2469FA9-EBD8-4834-A16D-CBF8EFC907DD}" dt="2025-10-01T23:36:27.191" v="2459" actId="1440"/>
-          <ac:picMkLst>
-            <pc:docMk/>
-            <pc:sldMk cId="314853837" sldId="279"/>
-            <ac:picMk id="5" creationId="{A780357E-1A13-135E-DB9A-EAD939954B87}"/>
-          </ac:picMkLst>
-        </pc:picChg>
-        <pc:picChg chg="add mod">
-          <ac:chgData name="Jonathan Bollig" userId="8b5d0afe-f106-45e0-8c3f-fd98fa124db1" providerId="ADAL" clId="{B2469FA9-EBD8-4834-A16D-CBF8EFC907DD}" dt="2025-10-01T23:38:38.538" v="2537" actId="1440"/>
-          <ac:picMkLst>
-            <pc:docMk/>
-            <pc:sldMk cId="314853837" sldId="279"/>
-            <ac:picMk id="7" creationId="{3F80AA20-93D4-563E-C7F6-0CD7E65044DC}"/>
-          </ac:picMkLst>
-        </pc:picChg>
-      </pc:sldChg>
-      <pc:sldChg chg="new del">
-        <pc:chgData name="Jonathan Bollig" userId="8b5d0afe-f106-45e0-8c3f-fd98fa124db1" providerId="ADAL" clId="{B2469FA9-EBD8-4834-A16D-CBF8EFC907DD}" dt="2025-10-01T22:53:57.755" v="2143" actId="47"/>
-        <pc:sldMkLst>
-          <pc:docMk/>
-          <pc:sldMk cId="3183787445" sldId="279"/>
-        </pc:sldMkLst>
-      </pc:sldChg>
-    </pc:docChg>
-  </pc:docChgLst>
-</pc:chgInfo>
-</file>
-
 <file path=ppt/notesMasters/notesMaster1.xml><?xml version="1.0" encoding="utf-8"?>
 <p:notesMaster xmlns:a="http://schemas.openxmlformats.org/drawingml/2006/main" xmlns:r="http://schemas.openxmlformats.org/officeDocument/2006/relationships" xmlns:p="http://schemas.openxmlformats.org/presentationml/2006/main">
   <p:cSld>
@@ -1078,7 +216,7 @@
           <a:p>
             <a:fld id="{0B6CA2EE-5589-4682-AD7F-744DBF1E81F5}" type="datetimeFigureOut">
               <a:rPr lang="de-DE" smtClean="0"/>
-              <a:t>05.10.2025</a:t>
+              <a:t>07.10.2025</a:t>
             </a:fld>
             <a:endParaRPr lang="de-DE"/>
           </a:p>
@@ -1236,7 +374,7 @@
           <a:p>
             <a:fld id="{11422C3B-6429-4381-8F08-B422F3CD22BF}" type="slidenum">
               <a:rPr lang="de-DE" smtClean="0"/>
-              <a:t>‹Nr.›</a:t>
+              <a:t>‹#›</a:t>
             </a:fld>
             <a:endParaRPr lang="de-DE"/>
           </a:p>
@@ -1934,7 +1072,7 @@
           <a:p>
             <a:fld id="{ADA51F25-4808-47F4-BF6E-BCDC230DB01C}" type="datetimeFigureOut">
               <a:rPr lang="de-DE" smtClean="0"/>
-              <a:t>05.10.2025</a:t>
+              <a:t>07.10.2025</a:t>
             </a:fld>
             <a:endParaRPr lang="de-DE"/>
           </a:p>
@@ -1988,7 +1126,7 @@
           <a:p>
             <a:fld id="{C018A060-D51C-4243-8F88-61D66D5570B8}" type="slidenum">
               <a:rPr lang="de-DE" smtClean="0"/>
-              <a:t>‹Nr.›</a:t>
+              <a:t>‹#›</a:t>
             </a:fld>
             <a:endParaRPr lang="de-DE"/>
           </a:p>
@@ -2132,7 +1270,7 @@
           <a:p>
             <a:fld id="{ADA51F25-4808-47F4-BF6E-BCDC230DB01C}" type="datetimeFigureOut">
               <a:rPr lang="de-DE" smtClean="0"/>
-              <a:t>05.10.2025</a:t>
+              <a:t>07.10.2025</a:t>
             </a:fld>
             <a:endParaRPr lang="de-DE"/>
           </a:p>
@@ -2186,7 +1324,7 @@
           <a:p>
             <a:fld id="{C018A060-D51C-4243-8F88-61D66D5570B8}" type="slidenum">
               <a:rPr lang="de-DE" smtClean="0"/>
-              <a:t>‹Nr.›</a:t>
+              <a:t>‹#›</a:t>
             </a:fld>
             <a:endParaRPr lang="de-DE"/>
           </a:p>
@@ -2340,7 +1478,7 @@
           <a:p>
             <a:fld id="{ADA51F25-4808-47F4-BF6E-BCDC230DB01C}" type="datetimeFigureOut">
               <a:rPr lang="de-DE" smtClean="0"/>
-              <a:t>05.10.2025</a:t>
+              <a:t>07.10.2025</a:t>
             </a:fld>
             <a:endParaRPr lang="de-DE"/>
           </a:p>
@@ -2394,7 +1532,7 @@
           <a:p>
             <a:fld id="{C018A060-D51C-4243-8F88-61D66D5570B8}" type="slidenum">
               <a:rPr lang="de-DE" smtClean="0"/>
-              <a:t>‹Nr.›</a:t>
+              <a:t>‹#›</a:t>
             </a:fld>
             <a:endParaRPr lang="de-DE"/>
           </a:p>
@@ -2538,7 +1676,7 @@
           <a:p>
             <a:fld id="{ADA51F25-4808-47F4-BF6E-BCDC230DB01C}" type="datetimeFigureOut">
               <a:rPr lang="de-DE" smtClean="0"/>
-              <a:t>05.10.2025</a:t>
+              <a:t>07.10.2025</a:t>
             </a:fld>
             <a:endParaRPr lang="de-DE"/>
           </a:p>
@@ -2592,7 +1730,7 @@
           <a:p>
             <a:fld id="{C018A060-D51C-4243-8F88-61D66D5570B8}" type="slidenum">
               <a:rPr lang="de-DE" smtClean="0"/>
-              <a:t>‹Nr.›</a:t>
+              <a:t>‹#›</a:t>
             </a:fld>
             <a:endParaRPr lang="de-DE"/>
           </a:p>
@@ -2813,7 +1951,7 @@
           <a:p>
             <a:fld id="{ADA51F25-4808-47F4-BF6E-BCDC230DB01C}" type="datetimeFigureOut">
               <a:rPr lang="de-DE" smtClean="0"/>
-              <a:t>05.10.2025</a:t>
+              <a:t>07.10.2025</a:t>
             </a:fld>
             <a:endParaRPr lang="de-DE"/>
           </a:p>
@@ -2867,7 +2005,7 @@
           <a:p>
             <a:fld id="{C018A060-D51C-4243-8F88-61D66D5570B8}" type="slidenum">
               <a:rPr lang="de-DE" smtClean="0"/>
-              <a:t>‹Nr.›</a:t>
+              <a:t>‹#›</a:t>
             </a:fld>
             <a:endParaRPr lang="de-DE"/>
           </a:p>
@@ -3078,7 +2216,7 @@
           <a:p>
             <a:fld id="{ADA51F25-4808-47F4-BF6E-BCDC230DB01C}" type="datetimeFigureOut">
               <a:rPr lang="de-DE" smtClean="0"/>
-              <a:t>05.10.2025</a:t>
+              <a:t>07.10.2025</a:t>
             </a:fld>
             <a:endParaRPr lang="de-DE"/>
           </a:p>
@@ -3132,7 +2270,7 @@
           <a:p>
             <a:fld id="{C018A060-D51C-4243-8F88-61D66D5570B8}" type="slidenum">
               <a:rPr lang="de-DE" smtClean="0"/>
-              <a:t>‹Nr.›</a:t>
+              <a:t>‹#›</a:t>
             </a:fld>
             <a:endParaRPr lang="de-DE"/>
           </a:p>
@@ -3490,7 +2628,7 @@
           <a:p>
             <a:fld id="{ADA51F25-4808-47F4-BF6E-BCDC230DB01C}" type="datetimeFigureOut">
               <a:rPr lang="de-DE" smtClean="0"/>
-              <a:t>05.10.2025</a:t>
+              <a:t>07.10.2025</a:t>
             </a:fld>
             <a:endParaRPr lang="de-DE"/>
           </a:p>
@@ -3544,7 +2682,7 @@
           <a:p>
             <a:fld id="{C018A060-D51C-4243-8F88-61D66D5570B8}" type="slidenum">
               <a:rPr lang="de-DE" smtClean="0"/>
-              <a:t>‹Nr.›</a:t>
+              <a:t>‹#›</a:t>
             </a:fld>
             <a:endParaRPr lang="de-DE"/>
           </a:p>
@@ -3631,7 +2769,7 @@
           <a:p>
             <a:fld id="{ADA51F25-4808-47F4-BF6E-BCDC230DB01C}" type="datetimeFigureOut">
               <a:rPr lang="de-DE" smtClean="0"/>
-              <a:t>05.10.2025</a:t>
+              <a:t>07.10.2025</a:t>
             </a:fld>
             <a:endParaRPr lang="de-DE"/>
           </a:p>
@@ -3685,7 +2823,7 @@
           <a:p>
             <a:fld id="{C018A060-D51C-4243-8F88-61D66D5570B8}" type="slidenum">
               <a:rPr lang="de-DE" smtClean="0"/>
-              <a:t>‹Nr.›</a:t>
+              <a:t>‹#›</a:t>
             </a:fld>
             <a:endParaRPr lang="de-DE"/>
           </a:p>
@@ -3744,7 +2882,7 @@
           <a:p>
             <a:fld id="{ADA51F25-4808-47F4-BF6E-BCDC230DB01C}" type="datetimeFigureOut">
               <a:rPr lang="de-DE" smtClean="0"/>
-              <a:t>05.10.2025</a:t>
+              <a:t>07.10.2025</a:t>
             </a:fld>
             <a:endParaRPr lang="de-DE"/>
           </a:p>
@@ -3798,7 +2936,7 @@
           <a:p>
             <a:fld id="{C018A060-D51C-4243-8F88-61D66D5570B8}" type="slidenum">
               <a:rPr lang="de-DE" smtClean="0"/>
-              <a:t>‹Nr.›</a:t>
+              <a:t>‹#›</a:t>
             </a:fld>
             <a:endParaRPr lang="de-DE"/>
           </a:p>
@@ -4055,7 +3193,7 @@
           <a:p>
             <a:fld id="{ADA51F25-4808-47F4-BF6E-BCDC230DB01C}" type="datetimeFigureOut">
               <a:rPr lang="de-DE" smtClean="0"/>
-              <a:t>05.10.2025</a:t>
+              <a:t>07.10.2025</a:t>
             </a:fld>
             <a:endParaRPr lang="de-DE"/>
           </a:p>
@@ -4109,7 +3247,7 @@
           <a:p>
             <a:fld id="{C018A060-D51C-4243-8F88-61D66D5570B8}" type="slidenum">
               <a:rPr lang="de-DE" smtClean="0"/>
-              <a:t>‹Nr.›</a:t>
+              <a:t>‹#›</a:t>
             </a:fld>
             <a:endParaRPr lang="de-DE"/>
           </a:p>
@@ -4343,7 +3481,7 @@
           <a:p>
             <a:fld id="{ADA51F25-4808-47F4-BF6E-BCDC230DB01C}" type="datetimeFigureOut">
               <a:rPr lang="de-DE" smtClean="0"/>
-              <a:t>05.10.2025</a:t>
+              <a:t>07.10.2025</a:t>
             </a:fld>
             <a:endParaRPr lang="de-DE"/>
           </a:p>
@@ -4397,7 +3535,7 @@
           <a:p>
             <a:fld id="{C018A060-D51C-4243-8F88-61D66D5570B8}" type="slidenum">
               <a:rPr lang="de-DE" smtClean="0"/>
-              <a:t>‹Nr.›</a:t>
+              <a:t>‹#›</a:t>
             </a:fld>
             <a:endParaRPr lang="de-DE"/>
           </a:p>
@@ -4584,7 +3722,7 @@
           <a:p>
             <a:fld id="{ADA51F25-4808-47F4-BF6E-BCDC230DB01C}" type="datetimeFigureOut">
               <a:rPr lang="de-DE" smtClean="0"/>
-              <a:t>05.10.2025</a:t>
+              <a:t>07.10.2025</a:t>
             </a:fld>
             <a:endParaRPr lang="de-DE"/>
           </a:p>
@@ -4674,7 +3812,7 @@
           <a:p>
             <a:fld id="{C018A060-D51C-4243-8F88-61D66D5570B8}" type="slidenum">
               <a:rPr lang="de-DE" smtClean="0"/>
-              <a:t>‹Nr.›</a:t>
+              <a:t>‹#›</a:t>
             </a:fld>
             <a:endParaRPr lang="de-DE"/>
           </a:p>
@@ -5019,7 +4157,9 @@
         </p:nvSpPr>
         <p:spPr/>
         <p:txBody>
-          <a:bodyPr/>
+          <a:bodyPr>
+            <a:normAutofit fontScale="90000"/>
+          </a:bodyPr>
           <a:lstStyle/>
           <a:p>
             <a:r>
@@ -5029,13 +4169,12 @@
             <a:br>
               <a:rPr lang="en-US" noProof="0" dirty="0"/>
             </a:br>
-            <a:r>
-              <a:rPr lang="en-US" noProof="0"/>
-              <a:t>Chunk 2: </a:t>
-            </a:r>
-            <a:r>
+            <a:br>
               <a:rPr lang="en-US" noProof="0" dirty="0"/>
-              <a:t>Variables</a:t>
+            </a:br>
+            <a:r>
+              <a:rPr lang="en-US" b="1" noProof="0" dirty="0"/>
+              <a:t>Chunk 2: Variables</a:t>
             </a:r>
           </a:p>
         </p:txBody>
@@ -5056,7 +4195,12 @@
             <p:ph type="subTitle" idx="1"/>
           </p:nvPr>
         </p:nvSpPr>
-        <p:spPr/>
+        <p:spPr>
+          <a:xfrm>
+            <a:off x="1524000" y="4238646"/>
+            <a:ext cx="9144000" cy="1655762"/>
+          </a:xfrm>
+        </p:spPr>
         <p:txBody>
           <a:bodyPr/>
           <a:lstStyle/>
@@ -5422,7 +4566,9 @@
         </p:nvSpPr>
         <p:spPr/>
         <p:txBody>
-          <a:bodyPr/>
+          <a:bodyPr>
+            <a:normAutofit lnSpcReduction="10000"/>
+          </a:bodyPr>
           <a:lstStyle/>
           <a:p>
             <a:r>
@@ -5438,6 +4584,11 @@
               </a:rPr>
               <a:t> Concatenate string and int:</a:t>
             </a:r>
+          </a:p>
+          <a:p>
+            <a:endParaRPr lang="en-US" dirty="0">
+              <a:sym typeface="Wingdings" panose="05000000000000000000" pitchFamily="2" charset="2"/>
+            </a:endParaRPr>
           </a:p>
           <a:p>
             <a:endParaRPr lang="en-US" dirty="0">
@@ -5500,7 +4651,7 @@
         </p:blipFill>
         <p:spPr>
           <a:xfrm>
-            <a:off x="6212238" y="3847146"/>
+            <a:off x="7439155" y="3470003"/>
             <a:ext cx="4336019" cy="1062582"/>
           </a:xfrm>
           <a:prstGeom prst="rect">
@@ -5580,7 +4731,7 @@
         </p:blipFill>
         <p:spPr>
           <a:xfrm>
-            <a:off x="8043373" y="5093442"/>
+            <a:off x="8441807" y="4758592"/>
             <a:ext cx="2330713" cy="1753514"/>
           </a:xfrm>
           <a:prstGeom prst="rect">
@@ -5608,6 +4759,188 @@
   <p:clrMapOvr>
     <a:masterClrMapping/>
   </p:clrMapOvr>
+  <p:timing>
+    <p:tnLst>
+      <p:par>
+        <p:cTn id="1" dur="indefinite" restart="never" nodeType="tmRoot">
+          <p:childTnLst>
+            <p:seq concurrent="1" nextAc="seek">
+              <p:cTn id="2" dur="indefinite" nodeType="mainSeq">
+                <p:childTnLst>
+                  <p:par>
+                    <p:cTn id="3" fill="hold">
+                      <p:stCondLst>
+                        <p:cond delay="indefinite"/>
+                      </p:stCondLst>
+                      <p:childTnLst>
+                        <p:par>
+                          <p:cTn id="4" fill="hold">
+                            <p:stCondLst>
+                              <p:cond delay="0"/>
+                            </p:stCondLst>
+                            <p:childTnLst>
+                              <p:par>
+                                <p:cTn id="5" presetID="1" presetClass="entr" presetSubtype="0" fill="hold" nodeType="clickEffect">
+                                  <p:stCondLst>
+                                    <p:cond delay="0"/>
+                                  </p:stCondLst>
+                                  <p:childTnLst>
+                                    <p:set>
+                                      <p:cBhvr>
+                                        <p:cTn id="6" dur="1" fill="hold">
+                                          <p:stCondLst>
+                                            <p:cond delay="0"/>
+                                          </p:stCondLst>
+                                        </p:cTn>
+                                        <p:tgtEl>
+                                          <p:spTgt spid="3">
+                                            <p:txEl>
+                                              <p:pRg st="3" end="3"/>
+                                            </p:txEl>
+                                          </p:spTgt>
+                                        </p:tgtEl>
+                                        <p:attrNameLst>
+                                          <p:attrName>style.visibility</p:attrName>
+                                        </p:attrNameLst>
+                                      </p:cBhvr>
+                                      <p:to>
+                                        <p:strVal val="visible"/>
+                                      </p:to>
+                                    </p:set>
+                                  </p:childTnLst>
+                                </p:cTn>
+                              </p:par>
+                              <p:par>
+                                <p:cTn id="7" presetID="1" presetClass="entr" presetSubtype="0" fill="hold" nodeType="withEffect">
+                                  <p:stCondLst>
+                                    <p:cond delay="0"/>
+                                  </p:stCondLst>
+                                  <p:childTnLst>
+                                    <p:set>
+                                      <p:cBhvr>
+                                        <p:cTn id="8" dur="1" fill="hold">
+                                          <p:stCondLst>
+                                            <p:cond delay="0"/>
+                                          </p:stCondLst>
+                                        </p:cTn>
+                                        <p:tgtEl>
+                                          <p:spTgt spid="11"/>
+                                        </p:tgtEl>
+                                        <p:attrNameLst>
+                                          <p:attrName>style.visibility</p:attrName>
+                                        </p:attrNameLst>
+                                      </p:cBhvr>
+                                      <p:to>
+                                        <p:strVal val="visible"/>
+                                      </p:to>
+                                    </p:set>
+                                  </p:childTnLst>
+                                </p:cTn>
+                              </p:par>
+                            </p:childTnLst>
+                          </p:cTn>
+                        </p:par>
+                      </p:childTnLst>
+                    </p:cTn>
+                  </p:par>
+                  <p:par>
+                    <p:cTn id="9" fill="hold">
+                      <p:stCondLst>
+                        <p:cond delay="indefinite"/>
+                      </p:stCondLst>
+                      <p:childTnLst>
+                        <p:par>
+                          <p:cTn id="10" fill="hold">
+                            <p:stCondLst>
+                              <p:cond delay="0"/>
+                            </p:stCondLst>
+                            <p:childTnLst>
+                              <p:par>
+                                <p:cTn id="11" presetID="1" presetClass="entr" presetSubtype="0" fill="hold" nodeType="clickEffect">
+                                  <p:stCondLst>
+                                    <p:cond delay="0"/>
+                                  </p:stCondLst>
+                                  <p:childTnLst>
+                                    <p:set>
+                                      <p:cBhvr>
+                                        <p:cTn id="12" dur="1" fill="hold">
+                                          <p:stCondLst>
+                                            <p:cond delay="0"/>
+                                          </p:stCondLst>
+                                        </p:cTn>
+                                        <p:tgtEl>
+                                          <p:spTgt spid="3">
+                                            <p:txEl>
+                                              <p:pRg st="7" end="7"/>
+                                            </p:txEl>
+                                          </p:spTgt>
+                                        </p:tgtEl>
+                                        <p:attrNameLst>
+                                          <p:attrName>style.visibility</p:attrName>
+                                        </p:attrNameLst>
+                                      </p:cBhvr>
+                                      <p:to>
+                                        <p:strVal val="visible"/>
+                                      </p:to>
+                                    </p:set>
+                                  </p:childTnLst>
+                                </p:cTn>
+                              </p:par>
+                              <p:par>
+                                <p:cTn id="13" presetID="1" presetClass="entr" presetSubtype="0" fill="hold" nodeType="withEffect">
+                                  <p:stCondLst>
+                                    <p:cond delay="0"/>
+                                  </p:stCondLst>
+                                  <p:childTnLst>
+                                    <p:set>
+                                      <p:cBhvr>
+                                        <p:cTn id="14" dur="1" fill="hold">
+                                          <p:stCondLst>
+                                            <p:cond delay="0"/>
+                                          </p:stCondLst>
+                                        </p:cTn>
+                                        <p:tgtEl>
+                                          <p:spTgt spid="5"/>
+                                        </p:tgtEl>
+                                        <p:attrNameLst>
+                                          <p:attrName>style.visibility</p:attrName>
+                                        </p:attrNameLst>
+                                      </p:cBhvr>
+                                      <p:to>
+                                        <p:strVal val="visible"/>
+                                      </p:to>
+                                    </p:set>
+                                  </p:childTnLst>
+                                </p:cTn>
+                              </p:par>
+                            </p:childTnLst>
+                          </p:cTn>
+                        </p:par>
+                      </p:childTnLst>
+                    </p:cTn>
+                  </p:par>
+                </p:childTnLst>
+              </p:cTn>
+              <p:prevCondLst>
+                <p:cond evt="onPrev" delay="0">
+                  <p:tgtEl>
+                    <p:sldTgt/>
+                  </p:tgtEl>
+                </p:cond>
+              </p:prevCondLst>
+              <p:nextCondLst>
+                <p:cond evt="onNext" delay="0">
+                  <p:tgtEl>
+                    <p:sldTgt/>
+                  </p:tgtEl>
+                </p:cond>
+              </p:nextCondLst>
+            </p:seq>
+          </p:childTnLst>
+        </p:cTn>
+      </p:par>
+    </p:tnLst>
+  </p:timing>
 </p:sld>
 </file>
 
@@ -6071,6 +5404,9 @@
               <a:rPr lang="en-US" dirty="0"/>
               <a:t>Print Statement:</a:t>
             </a:r>
+          </a:p>
+          <a:p>
+            <a:endParaRPr lang="en-US" dirty="0"/>
           </a:p>
           <a:p>
             <a:endParaRPr lang="en-US" dirty="0"/>
@@ -6209,7 +5545,7 @@
         </p:blipFill>
         <p:spPr>
           <a:xfrm>
-            <a:off x="8356001" y="1253765"/>
+            <a:off x="8520000" y="1447972"/>
             <a:ext cx="3100082" cy="1143719"/>
           </a:xfrm>
           <a:prstGeom prst="rect">
@@ -6249,7 +5585,7 @@
         </p:blipFill>
         <p:spPr>
           <a:xfrm>
-            <a:off x="3630566" y="2607343"/>
+            <a:off x="4591264" y="3085238"/>
             <a:ext cx="2086946" cy="758888"/>
           </a:xfrm>
           <a:prstGeom prst="rect">
@@ -6281,7 +5617,7 @@
         </p:nvCxnSpPr>
         <p:spPr>
           <a:xfrm>
-            <a:off x="6266153" y="3076584"/>
+            <a:off x="7226851" y="3554479"/>
             <a:ext cx="804672" cy="0"/>
           </a:xfrm>
           <a:prstGeom prst="straightConnector1">
@@ -6335,7 +5671,7 @@
         </p:blipFill>
         <p:spPr>
           <a:xfrm>
-            <a:off x="7819097" y="2607343"/>
+            <a:off x="8779795" y="3085238"/>
             <a:ext cx="2086945" cy="1014338"/>
           </a:xfrm>
           <a:prstGeom prst="rect">
@@ -6375,7 +5711,7 @@
         </p:blipFill>
         <p:spPr>
           <a:xfrm>
-            <a:off x="5333080" y="4042672"/>
+            <a:off x="5673431" y="4484476"/>
             <a:ext cx="4149836" cy="1659935"/>
           </a:xfrm>
           <a:prstGeom prst="rect">
@@ -6403,6 +5739,242 @@
   <p:clrMapOvr>
     <a:masterClrMapping/>
   </p:clrMapOvr>
+  <p:timing>
+    <p:tnLst>
+      <p:par>
+        <p:cTn id="1" dur="indefinite" restart="never" nodeType="tmRoot">
+          <p:childTnLst>
+            <p:seq concurrent="1" nextAc="seek">
+              <p:cTn id="2" dur="indefinite" nodeType="mainSeq">
+                <p:childTnLst>
+                  <p:par>
+                    <p:cTn id="3" fill="hold">
+                      <p:stCondLst>
+                        <p:cond delay="indefinite"/>
+                      </p:stCondLst>
+                      <p:childTnLst>
+                        <p:par>
+                          <p:cTn id="4" fill="hold">
+                            <p:stCondLst>
+                              <p:cond delay="0"/>
+                            </p:stCondLst>
+                            <p:childTnLst>
+                              <p:par>
+                                <p:cTn id="5" presetID="1" presetClass="entr" presetSubtype="0" fill="hold" nodeType="clickEffect">
+                                  <p:stCondLst>
+                                    <p:cond delay="0"/>
+                                  </p:stCondLst>
+                                  <p:childTnLst>
+                                    <p:set>
+                                      <p:cBhvr>
+                                        <p:cTn id="6" dur="1" fill="hold">
+                                          <p:stCondLst>
+                                            <p:cond delay="0"/>
+                                          </p:stCondLst>
+                                        </p:cTn>
+                                        <p:tgtEl>
+                                          <p:spTgt spid="3">
+                                            <p:txEl>
+                                              <p:pRg st="3" end="3"/>
+                                            </p:txEl>
+                                          </p:spTgt>
+                                        </p:tgtEl>
+                                        <p:attrNameLst>
+                                          <p:attrName>style.visibility</p:attrName>
+                                        </p:attrNameLst>
+                                      </p:cBhvr>
+                                      <p:to>
+                                        <p:strVal val="visible"/>
+                                      </p:to>
+                                    </p:set>
+                                  </p:childTnLst>
+                                </p:cTn>
+                              </p:par>
+                              <p:par>
+                                <p:cTn id="7" presetID="1" presetClass="entr" presetSubtype="0" fill="hold" nodeType="withEffect">
+                                  <p:stCondLst>
+                                    <p:cond delay="0"/>
+                                  </p:stCondLst>
+                                  <p:childTnLst>
+                                    <p:set>
+                                      <p:cBhvr>
+                                        <p:cTn id="8" dur="1" fill="hold">
+                                          <p:stCondLst>
+                                            <p:cond delay="0"/>
+                                          </p:stCondLst>
+                                        </p:cTn>
+                                        <p:tgtEl>
+                                          <p:spTgt spid="10"/>
+                                        </p:tgtEl>
+                                        <p:attrNameLst>
+                                          <p:attrName>style.visibility</p:attrName>
+                                        </p:attrNameLst>
+                                      </p:cBhvr>
+                                      <p:to>
+                                        <p:strVal val="visible"/>
+                                      </p:to>
+                                    </p:set>
+                                  </p:childTnLst>
+                                </p:cTn>
+                              </p:par>
+                              <p:par>
+                                <p:cTn id="9" presetID="1" presetClass="entr" presetSubtype="0" fill="hold" nodeType="withEffect">
+                                  <p:stCondLst>
+                                    <p:cond delay="0"/>
+                                  </p:stCondLst>
+                                  <p:childTnLst>
+                                    <p:set>
+                                      <p:cBhvr>
+                                        <p:cTn id="10" dur="1" fill="hold">
+                                          <p:stCondLst>
+                                            <p:cond delay="0"/>
+                                          </p:stCondLst>
+                                        </p:cTn>
+                                        <p:tgtEl>
+                                          <p:spTgt spid="13"/>
+                                        </p:tgtEl>
+                                        <p:attrNameLst>
+                                          <p:attrName>style.visibility</p:attrName>
+                                        </p:attrNameLst>
+                                      </p:cBhvr>
+                                      <p:to>
+                                        <p:strVal val="visible"/>
+                                      </p:to>
+                                    </p:set>
+                                  </p:childTnLst>
+                                </p:cTn>
+                              </p:par>
+                              <p:par>
+                                <p:cTn id="11" presetID="1" presetClass="entr" presetSubtype="0" fill="hold" nodeType="withEffect">
+                                  <p:stCondLst>
+                                    <p:cond delay="0"/>
+                                  </p:stCondLst>
+                                  <p:childTnLst>
+                                    <p:set>
+                                      <p:cBhvr>
+                                        <p:cTn id="12" dur="1" fill="hold">
+                                          <p:stCondLst>
+                                            <p:cond delay="0"/>
+                                          </p:stCondLst>
+                                        </p:cTn>
+                                        <p:tgtEl>
+                                          <p:spTgt spid="17"/>
+                                        </p:tgtEl>
+                                        <p:attrNameLst>
+                                          <p:attrName>style.visibility</p:attrName>
+                                        </p:attrNameLst>
+                                      </p:cBhvr>
+                                      <p:to>
+                                        <p:strVal val="visible"/>
+                                      </p:to>
+                                    </p:set>
+                                  </p:childTnLst>
+                                </p:cTn>
+                              </p:par>
+                            </p:childTnLst>
+                          </p:cTn>
+                        </p:par>
+                      </p:childTnLst>
+                    </p:cTn>
+                  </p:par>
+                  <p:par>
+                    <p:cTn id="13" fill="hold">
+                      <p:stCondLst>
+                        <p:cond delay="indefinite"/>
+                      </p:stCondLst>
+                      <p:childTnLst>
+                        <p:par>
+                          <p:cTn id="14" fill="hold">
+                            <p:stCondLst>
+                              <p:cond delay="0"/>
+                            </p:stCondLst>
+                            <p:childTnLst>
+                              <p:par>
+                                <p:cTn id="15" presetID="1" presetClass="entr" presetSubtype="0" fill="hold" nodeType="clickEffect">
+                                  <p:stCondLst>
+                                    <p:cond delay="0"/>
+                                  </p:stCondLst>
+                                  <p:childTnLst>
+                                    <p:set>
+                                      <p:cBhvr>
+                                        <p:cTn id="16" dur="1" fill="hold">
+                                          <p:stCondLst>
+                                            <p:cond delay="0"/>
+                                          </p:stCondLst>
+                                        </p:cTn>
+                                        <p:tgtEl>
+                                          <p:spTgt spid="3">
+                                            <p:txEl>
+                                              <p:pRg st="6" end="6"/>
+                                            </p:txEl>
+                                          </p:spTgt>
+                                        </p:tgtEl>
+                                        <p:attrNameLst>
+                                          <p:attrName>style.visibility</p:attrName>
+                                        </p:attrNameLst>
+                                      </p:cBhvr>
+                                      <p:to>
+                                        <p:strVal val="visible"/>
+                                      </p:to>
+                                    </p:set>
+                                  </p:childTnLst>
+                                </p:cTn>
+                              </p:par>
+                              <p:par>
+                                <p:cTn id="17" presetID="1" presetClass="entr" presetSubtype="0" fill="hold" nodeType="withEffect">
+                                  <p:stCondLst>
+                                    <p:cond delay="0"/>
+                                  </p:stCondLst>
+                                  <p:childTnLst>
+                                    <p:set>
+                                      <p:cBhvr>
+                                        <p:cTn id="18" dur="1" fill="hold">
+                                          <p:stCondLst>
+                                            <p:cond delay="0"/>
+                                          </p:stCondLst>
+                                        </p:cTn>
+                                        <p:tgtEl>
+                                          <p:spTgt spid="19"/>
+                                        </p:tgtEl>
+                                        <p:attrNameLst>
+                                          <p:attrName>style.visibility</p:attrName>
+                                        </p:attrNameLst>
+                                      </p:cBhvr>
+                                      <p:to>
+                                        <p:strVal val="visible"/>
+                                      </p:to>
+                                    </p:set>
+                                  </p:childTnLst>
+                                </p:cTn>
+                              </p:par>
+                            </p:childTnLst>
+                          </p:cTn>
+                        </p:par>
+                      </p:childTnLst>
+                    </p:cTn>
+                  </p:par>
+                </p:childTnLst>
+              </p:cTn>
+              <p:prevCondLst>
+                <p:cond evt="onPrev" delay="0">
+                  <p:tgtEl>
+                    <p:sldTgt/>
+                  </p:tgtEl>
+                </p:cond>
+              </p:prevCondLst>
+              <p:nextCondLst>
+                <p:cond evt="onNext" delay="0">
+                  <p:tgtEl>
+                    <p:sldTgt/>
+                  </p:tgtEl>
+                </p:cond>
+              </p:nextCondLst>
+            </p:seq>
+          </p:childTnLst>
+        </p:cTn>
+      </p:par>
+    </p:tnLst>
+  </p:timing>
 </p:sld>
 </file>
 
@@ -6588,8 +6160,8 @@
         </p:blipFill>
         <p:spPr>
           <a:xfrm>
-            <a:off x="5467007" y="2305100"/>
-            <a:ext cx="4915586" cy="1581371"/>
+            <a:off x="5972537" y="2467732"/>
+            <a:ext cx="4410056" cy="1418739"/>
           </a:xfrm>
           <a:prstGeom prst="rect">
             <a:avLst/>
@@ -6628,8 +6200,8 @@
         </p:blipFill>
         <p:spPr>
           <a:xfrm>
-            <a:off x="5774115" y="4179659"/>
-            <a:ext cx="2641465" cy="2600576"/>
+            <a:off x="5972537" y="4365946"/>
+            <a:ext cx="2118952" cy="2086151"/>
           </a:xfrm>
           <a:prstGeom prst="rect">
             <a:avLst/>
@@ -6864,15 +6436,36 @@
               <a:rPr lang="de-DE" dirty="0"/>
             </a:br>
             <a:r>
-              <a:rPr lang="en-GB" dirty="0"/>
+              <a:rPr lang="en-GB" sz="2400" dirty="0">
+                <a:solidFill>
+                  <a:schemeClr val="tx1">
+                    <a:lumMod val="50000"/>
+                    <a:lumOff val="50000"/>
+                  </a:schemeClr>
+                </a:solidFill>
+              </a:rPr>
               <a:t>False, None, True, and, as, assert, async, await, break, case, class, continue, def, del, </a:t>
             </a:r>
             <a:r>
-              <a:rPr lang="en-GB" dirty="0" err="1"/>
+              <a:rPr lang="en-GB" sz="2400" dirty="0" err="1">
+                <a:solidFill>
+                  <a:schemeClr val="tx1">
+                    <a:lumMod val="50000"/>
+                    <a:lumOff val="50000"/>
+                  </a:schemeClr>
+                </a:solidFill>
+              </a:rPr>
               <a:t>elif</a:t>
             </a:r>
             <a:r>
-              <a:rPr lang="en-GB" dirty="0"/>
+              <a:rPr lang="en-GB" sz="2400" dirty="0">
+                <a:solidFill>
+                  <a:schemeClr val="tx1">
+                    <a:lumMod val="50000"/>
+                    <a:lumOff val="50000"/>
+                  </a:schemeClr>
+                </a:solidFill>
+              </a:rPr>
               <a:t>, else, except, finally, for, from, global, if, import, in, is, lambda, match, nonlocal, not, or, pass, raise, return, try, while, with, yield</a:t>
             </a:r>
           </a:p>
@@ -6906,7 +6499,7 @@
         </p:blipFill>
         <p:spPr>
           <a:xfrm>
-            <a:off x="3108381" y="5123561"/>
+            <a:off x="3038933" y="4774009"/>
             <a:ext cx="2506035" cy="1537891"/>
           </a:xfrm>
           <a:prstGeom prst="rect">
@@ -6934,6 +6527,161 @@
   <p:clrMapOvr>
     <a:masterClrMapping/>
   </p:clrMapOvr>
+  <p:timing>
+    <p:tnLst>
+      <p:par>
+        <p:cTn id="1" dur="indefinite" restart="never" nodeType="tmRoot">
+          <p:childTnLst>
+            <p:seq concurrent="1" nextAc="seek">
+              <p:cTn id="2" dur="indefinite" nodeType="mainSeq">
+                <p:childTnLst>
+                  <p:par>
+                    <p:cTn id="3" fill="hold">
+                      <p:stCondLst>
+                        <p:cond delay="indefinite"/>
+                      </p:stCondLst>
+                      <p:childTnLst>
+                        <p:par>
+                          <p:cTn id="4" fill="hold">
+                            <p:stCondLst>
+                              <p:cond delay="0"/>
+                            </p:stCondLst>
+                            <p:childTnLst>
+                              <p:par>
+                                <p:cTn id="5" presetID="1" presetClass="entr" presetSubtype="0" fill="hold" nodeType="clickEffect">
+                                  <p:stCondLst>
+                                    <p:cond delay="0"/>
+                                  </p:stCondLst>
+                                  <p:childTnLst>
+                                    <p:set>
+                                      <p:cBhvr>
+                                        <p:cTn id="6" dur="1" fill="hold">
+                                          <p:stCondLst>
+                                            <p:cond delay="0"/>
+                                          </p:stCondLst>
+                                        </p:cTn>
+                                        <p:tgtEl>
+                                          <p:spTgt spid="3">
+                                            <p:txEl>
+                                              <p:pRg st="2" end="2"/>
+                                            </p:txEl>
+                                          </p:spTgt>
+                                        </p:tgtEl>
+                                        <p:attrNameLst>
+                                          <p:attrName>style.visibility</p:attrName>
+                                        </p:attrNameLst>
+                                      </p:cBhvr>
+                                      <p:to>
+                                        <p:strVal val="visible"/>
+                                      </p:to>
+                                    </p:set>
+                                  </p:childTnLst>
+                                </p:cTn>
+                              </p:par>
+                            </p:childTnLst>
+                          </p:cTn>
+                        </p:par>
+                      </p:childTnLst>
+                    </p:cTn>
+                  </p:par>
+                  <p:par>
+                    <p:cTn id="7" fill="hold">
+                      <p:stCondLst>
+                        <p:cond delay="indefinite"/>
+                      </p:stCondLst>
+                      <p:childTnLst>
+                        <p:par>
+                          <p:cTn id="8" fill="hold">
+                            <p:stCondLst>
+                              <p:cond delay="0"/>
+                            </p:stCondLst>
+                            <p:childTnLst>
+                              <p:par>
+                                <p:cTn id="9" presetID="1" presetClass="entr" presetSubtype="0" fill="hold" nodeType="clickEffect">
+                                  <p:stCondLst>
+                                    <p:cond delay="0"/>
+                                  </p:stCondLst>
+                                  <p:childTnLst>
+                                    <p:set>
+                                      <p:cBhvr>
+                                        <p:cTn id="10" dur="1" fill="hold">
+                                          <p:stCondLst>
+                                            <p:cond delay="0"/>
+                                          </p:stCondLst>
+                                        </p:cTn>
+                                        <p:tgtEl>
+                                          <p:spTgt spid="3">
+                                            <p:txEl>
+                                              <p:pRg st="3" end="3"/>
+                                            </p:txEl>
+                                          </p:spTgt>
+                                        </p:tgtEl>
+                                        <p:attrNameLst>
+                                          <p:attrName>style.visibility</p:attrName>
+                                        </p:attrNameLst>
+                                      </p:cBhvr>
+                                      <p:to>
+                                        <p:strVal val="visible"/>
+                                      </p:to>
+                                    </p:set>
+                                  </p:childTnLst>
+                                </p:cTn>
+                              </p:par>
+                              <p:par>
+                                <p:cTn id="11" presetID="1" presetClass="entr" presetSubtype="0" fill="hold" nodeType="withEffect">
+                                  <p:stCondLst>
+                                    <p:cond delay="0"/>
+                                  </p:stCondLst>
+                                  <p:childTnLst>
+                                    <p:set>
+                                      <p:cBhvr>
+                                        <p:cTn id="12" dur="1" fill="hold">
+                                          <p:stCondLst>
+                                            <p:cond delay="0"/>
+                                          </p:stCondLst>
+                                        </p:cTn>
+                                        <p:tgtEl>
+                                          <p:spTgt spid="5"/>
+                                        </p:tgtEl>
+                                        <p:attrNameLst>
+                                          <p:attrName>style.visibility</p:attrName>
+                                        </p:attrNameLst>
+                                      </p:cBhvr>
+                                      <p:to>
+                                        <p:strVal val="visible"/>
+                                      </p:to>
+                                    </p:set>
+                                  </p:childTnLst>
+                                </p:cTn>
+                              </p:par>
+                            </p:childTnLst>
+                          </p:cTn>
+                        </p:par>
+                      </p:childTnLst>
+                    </p:cTn>
+                  </p:par>
+                </p:childTnLst>
+              </p:cTn>
+              <p:prevCondLst>
+                <p:cond evt="onPrev" delay="0">
+                  <p:tgtEl>
+                    <p:sldTgt/>
+                  </p:tgtEl>
+                </p:cond>
+              </p:prevCondLst>
+              <p:nextCondLst>
+                <p:cond evt="onNext" delay="0">
+                  <p:tgtEl>
+                    <p:sldTgt/>
+                  </p:tgtEl>
+                </p:cond>
+              </p:nextCondLst>
+            </p:seq>
+          </p:childTnLst>
+        </p:cTn>
+      </p:par>
+    </p:tnLst>
+  </p:timing>
 </p:sld>
 </file>
 
@@ -7066,8 +6814,8 @@
         </p:blipFill>
         <p:spPr>
           <a:xfrm>
-            <a:off x="10812026" y="585708"/>
-            <a:ext cx="842223" cy="891766"/>
+            <a:off x="10812027" y="585708"/>
+            <a:ext cx="784936" cy="831109"/>
           </a:xfrm>
           <a:prstGeom prst="rect">
             <a:avLst/>
@@ -7440,7 +7188,7 @@
         </p:blipFill>
         <p:spPr>
           <a:xfrm>
-            <a:off x="838200" y="2300844"/>
+            <a:off x="1221828" y="2009363"/>
             <a:ext cx="4382112" cy="3400900"/>
           </a:xfrm>
           <a:prstGeom prst="rect">
@@ -7480,7 +7228,7 @@
         </p:blipFill>
         <p:spPr>
           <a:xfrm>
-            <a:off x="7744324" y="2730090"/>
+            <a:off x="7779804" y="2730833"/>
             <a:ext cx="2346445" cy="2346445"/>
           </a:xfrm>
           <a:prstGeom prst="rect">
@@ -7512,7 +7260,7 @@
         </p:nvCxnSpPr>
         <p:spPr>
           <a:xfrm>
-            <a:off x="6023318" y="3918969"/>
+            <a:off x="6289536" y="3840590"/>
             <a:ext cx="804672" cy="0"/>
           </a:xfrm>
           <a:prstGeom prst="straightConnector1">
@@ -7557,7 +7305,7 @@
         </p:nvSpPr>
         <p:spPr>
           <a:xfrm>
-            <a:off x="1221828" y="6053959"/>
+            <a:off x="1731114" y="6100793"/>
             <a:ext cx="7553286" cy="369332"/>
           </a:xfrm>
           <a:prstGeom prst="rect">
@@ -8186,6 +7934,354 @@
   <p:clrMapOvr>
     <a:masterClrMapping/>
   </p:clrMapOvr>
+  <p:timing>
+    <p:tnLst>
+      <p:par>
+        <p:cTn id="1" dur="indefinite" restart="never" nodeType="tmRoot">
+          <p:childTnLst>
+            <p:seq concurrent="1" nextAc="seek">
+              <p:cTn id="2" dur="indefinite" nodeType="mainSeq">
+                <p:childTnLst>
+                  <p:par>
+                    <p:cTn id="3" fill="hold">
+                      <p:stCondLst>
+                        <p:cond delay="indefinite"/>
+                      </p:stCondLst>
+                      <p:childTnLst>
+                        <p:par>
+                          <p:cTn id="4" fill="hold">
+                            <p:stCondLst>
+                              <p:cond delay="0"/>
+                            </p:stCondLst>
+                            <p:childTnLst>
+                              <p:par>
+                                <p:cTn id="5" presetID="1" presetClass="entr" presetSubtype="0" fill="hold" nodeType="clickEffect">
+                                  <p:stCondLst>
+                                    <p:cond delay="0"/>
+                                  </p:stCondLst>
+                                  <p:childTnLst>
+                                    <p:set>
+                                      <p:cBhvr>
+                                        <p:cTn id="6" dur="1" fill="hold">
+                                          <p:stCondLst>
+                                            <p:cond delay="0"/>
+                                          </p:stCondLst>
+                                        </p:cTn>
+                                        <p:tgtEl>
+                                          <p:spTgt spid="3">
+                                            <p:txEl>
+                                              <p:pRg st="4" end="4"/>
+                                            </p:txEl>
+                                          </p:spTgt>
+                                        </p:tgtEl>
+                                        <p:attrNameLst>
+                                          <p:attrName>style.visibility</p:attrName>
+                                        </p:attrNameLst>
+                                      </p:cBhvr>
+                                      <p:to>
+                                        <p:strVal val="visible"/>
+                                      </p:to>
+                                    </p:set>
+                                  </p:childTnLst>
+                                </p:cTn>
+                              </p:par>
+                              <p:par>
+                                <p:cTn id="7" presetID="1" presetClass="entr" presetSubtype="0" fill="hold" nodeType="withEffect">
+                                  <p:stCondLst>
+                                    <p:cond delay="0"/>
+                                  </p:stCondLst>
+                                  <p:childTnLst>
+                                    <p:set>
+                                      <p:cBhvr>
+                                        <p:cTn id="8" dur="1" fill="hold">
+                                          <p:stCondLst>
+                                            <p:cond delay="0"/>
+                                          </p:stCondLst>
+                                        </p:cTn>
+                                        <p:tgtEl>
+                                          <p:spTgt spid="9"/>
+                                        </p:tgtEl>
+                                        <p:attrNameLst>
+                                          <p:attrName>style.visibility</p:attrName>
+                                        </p:attrNameLst>
+                                      </p:cBhvr>
+                                      <p:to>
+                                        <p:strVal val="visible"/>
+                                      </p:to>
+                                    </p:set>
+                                  </p:childTnLst>
+                                </p:cTn>
+                              </p:par>
+                              <p:par>
+                                <p:cTn id="9" presetID="1" presetClass="entr" presetSubtype="0" fill="hold" nodeType="withEffect">
+                                  <p:stCondLst>
+                                    <p:cond delay="0"/>
+                                  </p:stCondLst>
+                                  <p:childTnLst>
+                                    <p:set>
+                                      <p:cBhvr>
+                                        <p:cTn id="10" dur="1" fill="hold">
+                                          <p:stCondLst>
+                                            <p:cond delay="0"/>
+                                          </p:stCondLst>
+                                        </p:cTn>
+                                        <p:tgtEl>
+                                          <p:spTgt spid="11"/>
+                                        </p:tgtEl>
+                                        <p:attrNameLst>
+                                          <p:attrName>style.visibility</p:attrName>
+                                        </p:attrNameLst>
+                                      </p:cBhvr>
+                                      <p:to>
+                                        <p:strVal val="visible"/>
+                                      </p:to>
+                                    </p:set>
+                                  </p:childTnLst>
+                                </p:cTn>
+                              </p:par>
+                              <p:par>
+                                <p:cTn id="11" presetID="1" presetClass="entr" presetSubtype="0" fill="hold" nodeType="withEffect">
+                                  <p:stCondLst>
+                                    <p:cond delay="0"/>
+                                  </p:stCondLst>
+                                  <p:childTnLst>
+                                    <p:set>
+                                      <p:cBhvr>
+                                        <p:cTn id="12" dur="1" fill="hold">
+                                          <p:stCondLst>
+                                            <p:cond delay="0"/>
+                                          </p:stCondLst>
+                                        </p:cTn>
+                                        <p:tgtEl>
+                                          <p:spTgt spid="12"/>
+                                        </p:tgtEl>
+                                        <p:attrNameLst>
+                                          <p:attrName>style.visibility</p:attrName>
+                                        </p:attrNameLst>
+                                      </p:cBhvr>
+                                      <p:to>
+                                        <p:strVal val="visible"/>
+                                      </p:to>
+                                    </p:set>
+                                  </p:childTnLst>
+                                </p:cTn>
+                              </p:par>
+                              <p:par>
+                                <p:cTn id="13" presetID="1" presetClass="entr" presetSubtype="0" fill="hold" nodeType="withEffect">
+                                  <p:stCondLst>
+                                    <p:cond delay="0"/>
+                                  </p:stCondLst>
+                                  <p:childTnLst>
+                                    <p:set>
+                                      <p:cBhvr>
+                                        <p:cTn id="14" dur="1" fill="hold">
+                                          <p:stCondLst>
+                                            <p:cond delay="0"/>
+                                          </p:stCondLst>
+                                        </p:cTn>
+                                        <p:tgtEl>
+                                          <p:spTgt spid="13"/>
+                                        </p:tgtEl>
+                                        <p:attrNameLst>
+                                          <p:attrName>style.visibility</p:attrName>
+                                        </p:attrNameLst>
+                                      </p:cBhvr>
+                                      <p:to>
+                                        <p:strVal val="visible"/>
+                                      </p:to>
+                                    </p:set>
+                                  </p:childTnLst>
+                                </p:cTn>
+                              </p:par>
+                            </p:childTnLst>
+                          </p:cTn>
+                        </p:par>
+                      </p:childTnLst>
+                    </p:cTn>
+                  </p:par>
+                  <p:par>
+                    <p:cTn id="15" fill="hold">
+                      <p:stCondLst>
+                        <p:cond delay="indefinite"/>
+                      </p:stCondLst>
+                      <p:childTnLst>
+                        <p:par>
+                          <p:cTn id="16" fill="hold">
+                            <p:stCondLst>
+                              <p:cond delay="0"/>
+                            </p:stCondLst>
+                            <p:childTnLst>
+                              <p:par>
+                                <p:cTn id="17" presetID="1" presetClass="entr" presetSubtype="0" fill="hold" nodeType="clickEffect">
+                                  <p:stCondLst>
+                                    <p:cond delay="0"/>
+                                  </p:stCondLst>
+                                  <p:childTnLst>
+                                    <p:set>
+                                      <p:cBhvr>
+                                        <p:cTn id="18" dur="1" fill="hold">
+                                          <p:stCondLst>
+                                            <p:cond delay="0"/>
+                                          </p:stCondLst>
+                                        </p:cTn>
+                                        <p:tgtEl>
+                                          <p:spTgt spid="3">
+                                            <p:txEl>
+                                              <p:pRg st="6" end="6"/>
+                                            </p:txEl>
+                                          </p:spTgt>
+                                        </p:tgtEl>
+                                        <p:attrNameLst>
+                                          <p:attrName>style.visibility</p:attrName>
+                                        </p:attrNameLst>
+                                      </p:cBhvr>
+                                      <p:to>
+                                        <p:strVal val="visible"/>
+                                      </p:to>
+                                    </p:set>
+                                  </p:childTnLst>
+                                </p:cTn>
+                              </p:par>
+                              <p:par>
+                                <p:cTn id="19" presetID="1" presetClass="entr" presetSubtype="0" fill="hold" nodeType="withEffect">
+                                  <p:stCondLst>
+                                    <p:cond delay="0"/>
+                                  </p:stCondLst>
+                                  <p:childTnLst>
+                                    <p:set>
+                                      <p:cBhvr>
+                                        <p:cTn id="20" dur="1" fill="hold">
+                                          <p:stCondLst>
+                                            <p:cond delay="0"/>
+                                          </p:stCondLst>
+                                        </p:cTn>
+                                        <p:tgtEl>
+                                          <p:spTgt spid="15"/>
+                                        </p:tgtEl>
+                                        <p:attrNameLst>
+                                          <p:attrName>style.visibility</p:attrName>
+                                        </p:attrNameLst>
+                                      </p:cBhvr>
+                                      <p:to>
+                                        <p:strVal val="visible"/>
+                                      </p:to>
+                                    </p:set>
+                                  </p:childTnLst>
+                                </p:cTn>
+                              </p:par>
+                              <p:par>
+                                <p:cTn id="21" presetID="1" presetClass="entr" presetSubtype="0" fill="hold" nodeType="withEffect">
+                                  <p:stCondLst>
+                                    <p:cond delay="0"/>
+                                  </p:stCondLst>
+                                  <p:childTnLst>
+                                    <p:set>
+                                      <p:cBhvr>
+                                        <p:cTn id="22" dur="1" fill="hold">
+                                          <p:stCondLst>
+                                            <p:cond delay="0"/>
+                                          </p:stCondLst>
+                                        </p:cTn>
+                                        <p:tgtEl>
+                                          <p:spTgt spid="18"/>
+                                        </p:tgtEl>
+                                        <p:attrNameLst>
+                                          <p:attrName>style.visibility</p:attrName>
+                                        </p:attrNameLst>
+                                      </p:cBhvr>
+                                      <p:to>
+                                        <p:strVal val="visible"/>
+                                      </p:to>
+                                    </p:set>
+                                  </p:childTnLst>
+                                </p:cTn>
+                              </p:par>
+                              <p:par>
+                                <p:cTn id="23" presetID="1" presetClass="entr" presetSubtype="0" fill="hold" grpId="0" nodeType="withEffect">
+                                  <p:stCondLst>
+                                    <p:cond delay="0"/>
+                                  </p:stCondLst>
+                                  <p:childTnLst>
+                                    <p:set>
+                                      <p:cBhvr>
+                                        <p:cTn id="24" dur="1" fill="hold">
+                                          <p:stCondLst>
+                                            <p:cond delay="0"/>
+                                          </p:stCondLst>
+                                        </p:cTn>
+                                        <p:tgtEl>
+                                          <p:spTgt spid="19"/>
+                                        </p:tgtEl>
+                                        <p:attrNameLst>
+                                          <p:attrName>style.visibility</p:attrName>
+                                        </p:attrNameLst>
+                                      </p:cBhvr>
+                                      <p:to>
+                                        <p:strVal val="visible"/>
+                                      </p:to>
+                                    </p:set>
+                                  </p:childTnLst>
+                                </p:cTn>
+                              </p:par>
+                              <p:par>
+                                <p:cTn id="25" presetID="1" presetClass="entr" presetSubtype="0" fill="hold" grpId="0" nodeType="withEffect">
+                                  <p:stCondLst>
+                                    <p:cond delay="0"/>
+                                  </p:stCondLst>
+                                  <p:childTnLst>
+                                    <p:set>
+                                      <p:cBhvr>
+                                        <p:cTn id="26" dur="1" fill="hold">
+                                          <p:stCondLst>
+                                            <p:cond delay="0"/>
+                                          </p:stCondLst>
+                                        </p:cTn>
+                                        <p:tgtEl>
+                                          <p:spTgt spid="16"/>
+                                        </p:tgtEl>
+                                        <p:attrNameLst>
+                                          <p:attrName>style.visibility</p:attrName>
+                                        </p:attrNameLst>
+                                      </p:cBhvr>
+                                      <p:to>
+                                        <p:strVal val="visible"/>
+                                      </p:to>
+                                    </p:set>
+                                  </p:childTnLst>
+                                </p:cTn>
+                              </p:par>
+                            </p:childTnLst>
+                          </p:cTn>
+                        </p:par>
+                      </p:childTnLst>
+                    </p:cTn>
+                  </p:par>
+                </p:childTnLst>
+              </p:cTn>
+              <p:prevCondLst>
+                <p:cond evt="onPrev" delay="0">
+                  <p:tgtEl>
+                    <p:sldTgt/>
+                  </p:tgtEl>
+                </p:cond>
+              </p:prevCondLst>
+              <p:nextCondLst>
+                <p:cond evt="onNext" delay="0">
+                  <p:tgtEl>
+                    <p:sldTgt/>
+                  </p:tgtEl>
+                </p:cond>
+              </p:nextCondLst>
+            </p:seq>
+          </p:childTnLst>
+        </p:cTn>
+      </p:par>
+    </p:tnLst>
+    <p:bldLst>
+      <p:bldP spid="16" grpId="0" animBg="1"/>
+      <p:bldP spid="19" grpId="0" animBg="1"/>
+    </p:bldLst>
+  </p:timing>
 </p:sld>
 </file>
 
@@ -8251,7 +8347,12 @@
             <p:ph idx="1"/>
           </p:nvPr>
         </p:nvSpPr>
-        <p:spPr/>
+        <p:spPr>
+          <a:xfrm>
+            <a:off x="1676400" y="1987821"/>
+            <a:ext cx="10515600" cy="4351338"/>
+          </a:xfrm>
+        </p:spPr>
         <p:txBody>
           <a:bodyPr/>
           <a:lstStyle/>
@@ -8323,8 +8424,8 @@
         </p:blipFill>
         <p:spPr>
           <a:xfrm>
-            <a:off x="5199010" y="1223847"/>
-            <a:ext cx="1285932" cy="2018614"/>
+            <a:off x="7582406" y="1497880"/>
+            <a:ext cx="1039744" cy="1632156"/>
           </a:xfrm>
           <a:prstGeom prst="rect">
             <a:avLst/>
@@ -8363,8 +8464,8 @@
         </p:blipFill>
         <p:spPr>
           <a:xfrm>
-            <a:off x="6541100" y="2924093"/>
-            <a:ext cx="1493305" cy="1554506"/>
+            <a:off x="8055866" y="3314733"/>
+            <a:ext cx="1319061" cy="1373121"/>
           </a:xfrm>
           <a:prstGeom prst="rect">
             <a:avLst/>
@@ -8403,7 +8504,7 @@
         </p:blipFill>
         <p:spPr>
           <a:xfrm>
-            <a:off x="4457476" y="4613536"/>
+            <a:off x="7469950" y="4984987"/>
             <a:ext cx="2490891" cy="1382042"/>
           </a:xfrm>
           <a:prstGeom prst="rect">
@@ -8443,8 +8544,8 @@
         </p:blipFill>
         <p:spPr>
           <a:xfrm>
-            <a:off x="8524767" y="1314155"/>
-            <a:ext cx="1543265" cy="2114845"/>
+            <a:off x="8779411" y="1497881"/>
+            <a:ext cx="1191033" cy="1632156"/>
           </a:xfrm>
           <a:prstGeom prst="rect">
             <a:avLst/>
@@ -8471,6 +8572,188 @@
   <p:clrMapOvr>
     <a:masterClrMapping/>
   </p:clrMapOvr>
+  <p:timing>
+    <p:tnLst>
+      <p:par>
+        <p:cTn id="1" dur="indefinite" restart="never" nodeType="tmRoot">
+          <p:childTnLst>
+            <p:seq concurrent="1" nextAc="seek">
+              <p:cTn id="2" dur="indefinite" nodeType="mainSeq">
+                <p:childTnLst>
+                  <p:par>
+                    <p:cTn id="3" fill="hold">
+                      <p:stCondLst>
+                        <p:cond delay="indefinite"/>
+                      </p:stCondLst>
+                      <p:childTnLst>
+                        <p:par>
+                          <p:cTn id="4" fill="hold">
+                            <p:stCondLst>
+                              <p:cond delay="0"/>
+                            </p:stCondLst>
+                            <p:childTnLst>
+                              <p:par>
+                                <p:cTn id="5" presetID="1" presetClass="entr" presetSubtype="0" fill="hold" nodeType="clickEffect">
+                                  <p:stCondLst>
+                                    <p:cond delay="0"/>
+                                  </p:stCondLst>
+                                  <p:childTnLst>
+                                    <p:set>
+                                      <p:cBhvr>
+                                        <p:cTn id="6" dur="1" fill="hold">
+                                          <p:stCondLst>
+                                            <p:cond delay="0"/>
+                                          </p:stCondLst>
+                                        </p:cTn>
+                                        <p:tgtEl>
+                                          <p:spTgt spid="3">
+                                            <p:txEl>
+                                              <p:pRg st="3" end="3"/>
+                                            </p:txEl>
+                                          </p:spTgt>
+                                        </p:tgtEl>
+                                        <p:attrNameLst>
+                                          <p:attrName>style.visibility</p:attrName>
+                                        </p:attrNameLst>
+                                      </p:cBhvr>
+                                      <p:to>
+                                        <p:strVal val="visible"/>
+                                      </p:to>
+                                    </p:set>
+                                  </p:childTnLst>
+                                </p:cTn>
+                              </p:par>
+                              <p:par>
+                                <p:cTn id="7" presetID="1" presetClass="entr" presetSubtype="0" fill="hold" nodeType="withEffect">
+                                  <p:stCondLst>
+                                    <p:cond delay="0"/>
+                                  </p:stCondLst>
+                                  <p:childTnLst>
+                                    <p:set>
+                                      <p:cBhvr>
+                                        <p:cTn id="8" dur="1" fill="hold">
+                                          <p:stCondLst>
+                                            <p:cond delay="0"/>
+                                          </p:stCondLst>
+                                        </p:cTn>
+                                        <p:tgtEl>
+                                          <p:spTgt spid="7"/>
+                                        </p:tgtEl>
+                                        <p:attrNameLst>
+                                          <p:attrName>style.visibility</p:attrName>
+                                        </p:attrNameLst>
+                                      </p:cBhvr>
+                                      <p:to>
+                                        <p:strVal val="visible"/>
+                                      </p:to>
+                                    </p:set>
+                                  </p:childTnLst>
+                                </p:cTn>
+                              </p:par>
+                            </p:childTnLst>
+                          </p:cTn>
+                        </p:par>
+                      </p:childTnLst>
+                    </p:cTn>
+                  </p:par>
+                  <p:par>
+                    <p:cTn id="9" fill="hold">
+                      <p:stCondLst>
+                        <p:cond delay="indefinite"/>
+                      </p:stCondLst>
+                      <p:childTnLst>
+                        <p:par>
+                          <p:cTn id="10" fill="hold">
+                            <p:stCondLst>
+                              <p:cond delay="0"/>
+                            </p:stCondLst>
+                            <p:childTnLst>
+                              <p:par>
+                                <p:cTn id="11" presetID="1" presetClass="entr" presetSubtype="0" fill="hold" nodeType="clickEffect">
+                                  <p:stCondLst>
+                                    <p:cond delay="0"/>
+                                  </p:stCondLst>
+                                  <p:childTnLst>
+                                    <p:set>
+                                      <p:cBhvr>
+                                        <p:cTn id="12" dur="1" fill="hold">
+                                          <p:stCondLst>
+                                            <p:cond delay="0"/>
+                                          </p:stCondLst>
+                                        </p:cTn>
+                                        <p:tgtEl>
+                                          <p:spTgt spid="3">
+                                            <p:txEl>
+                                              <p:pRg st="6" end="6"/>
+                                            </p:txEl>
+                                          </p:spTgt>
+                                        </p:tgtEl>
+                                        <p:attrNameLst>
+                                          <p:attrName>style.visibility</p:attrName>
+                                        </p:attrNameLst>
+                                      </p:cBhvr>
+                                      <p:to>
+                                        <p:strVal val="visible"/>
+                                      </p:to>
+                                    </p:set>
+                                  </p:childTnLst>
+                                </p:cTn>
+                              </p:par>
+                              <p:par>
+                                <p:cTn id="13" presetID="1" presetClass="entr" presetSubtype="0" fill="hold" nodeType="withEffect">
+                                  <p:stCondLst>
+                                    <p:cond delay="0"/>
+                                  </p:stCondLst>
+                                  <p:childTnLst>
+                                    <p:set>
+                                      <p:cBhvr>
+                                        <p:cTn id="14" dur="1" fill="hold">
+                                          <p:stCondLst>
+                                            <p:cond delay="0"/>
+                                          </p:stCondLst>
+                                        </p:cTn>
+                                        <p:tgtEl>
+                                          <p:spTgt spid="9"/>
+                                        </p:tgtEl>
+                                        <p:attrNameLst>
+                                          <p:attrName>style.visibility</p:attrName>
+                                        </p:attrNameLst>
+                                      </p:cBhvr>
+                                      <p:to>
+                                        <p:strVal val="visible"/>
+                                      </p:to>
+                                    </p:set>
+                                  </p:childTnLst>
+                                </p:cTn>
+                              </p:par>
+                            </p:childTnLst>
+                          </p:cTn>
+                        </p:par>
+                      </p:childTnLst>
+                    </p:cTn>
+                  </p:par>
+                </p:childTnLst>
+              </p:cTn>
+              <p:prevCondLst>
+                <p:cond evt="onPrev" delay="0">
+                  <p:tgtEl>
+                    <p:sldTgt/>
+                  </p:tgtEl>
+                </p:cond>
+              </p:prevCondLst>
+              <p:nextCondLst>
+                <p:cond evt="onNext" delay="0">
+                  <p:tgtEl>
+                    <p:sldTgt/>
+                  </p:tgtEl>
+                </p:cond>
+              </p:nextCondLst>
+            </p:seq>
+          </p:childTnLst>
+        </p:cTn>
+      </p:par>
+    </p:tnLst>
+  </p:timing>
 </p:sld>
 </file>
 
@@ -8568,7 +8851,7 @@
         <p:spPr>
           <a:xfrm>
             <a:off x="-1" y="2486025"/>
-            <a:ext cx="12557367" cy="2573083"/>
+            <a:ext cx="12192001" cy="2498217"/>
           </a:xfrm>
           <a:prstGeom prst="rect">
             <a:avLst/>

</xml_diff>